<commit_message>
mise à jour de la présentation
</commit_message>
<xml_diff>
--- a/reports/oc-projet-8.pptx
+++ b/reports/oc-projet-8.pptx
@@ -5,10 +5,10 @@
     <p:sldMasterId id="2147483677" r:id="rId1"/>
   </p:sldMasterIdLst>
   <p:notesMasterIdLst>
-    <p:notesMasterId r:id="rId12"/>
+    <p:notesMasterId r:id="rId13"/>
   </p:notesMasterIdLst>
   <p:handoutMasterIdLst>
-    <p:handoutMasterId r:id="rId13"/>
+    <p:handoutMasterId r:id="rId14"/>
   </p:handoutMasterIdLst>
   <p:sldIdLst>
     <p:sldId id="256" r:id="rId2"/>
@@ -19,8 +19,9 @@
     <p:sldId id="329" r:id="rId7"/>
     <p:sldId id="333" r:id="rId8"/>
     <p:sldId id="334" r:id="rId9"/>
-    <p:sldId id="335" r:id="rId10"/>
-    <p:sldId id="312" r:id="rId11"/>
+    <p:sldId id="336" r:id="rId10"/>
+    <p:sldId id="335" r:id="rId11"/>
+    <p:sldId id="312" r:id="rId12"/>
   </p:sldIdLst>
   <p:sldSz cx="12192000" cy="6858000"/>
   <p:notesSz cx="6858000" cy="9144000"/>
@@ -224,7 +225,7 @@
           <a:p>
             <a:fld id="{65DDB058-A044-4043-A3A3-7BACA5B3A04F}" type="datetimeFigureOut">
               <a:rPr lang="en-US" smtClean="0"/>
-              <a:t>8/14/2026</a:t>
+              <a:t>8/17/2026</a:t>
             </a:fld>
             <a:endParaRPr lang="en-US"/>
           </a:p>
@@ -302,7 +303,7 @@
           <a:p>
             <a:fld id="{EC4BEB73-50BC-478F-9973-E68CD0A30E97}" type="slidenum">
               <a:rPr lang="en-US" smtClean="0"/>
-              <a:t>‹N°›</a:t>
+              <a:t>‹#›</a:t>
             </a:fld>
             <a:endParaRPr lang="en-US"/>
           </a:p>
@@ -401,7 +402,7 @@
           <a:p>
             <a:fld id="{AA1CF6E6-CAE2-4C00-8C24-5E0E8B2FFA08}" type="datetimeFigureOut">
               <a:rPr lang="en-US" smtClean="0"/>
-              <a:t>8/14/2026</a:t>
+              <a:t>8/17/2026</a:t>
             </a:fld>
             <a:endParaRPr lang="en-US"/>
           </a:p>
@@ -560,7 +561,7 @@
           <a:p>
             <a:fld id="{A3F3624B-3861-4937-8F64-3EF5A72077AD}" type="slidenum">
               <a:rPr lang="en-US" smtClean="0"/>
-              <a:t>‹N°›</a:t>
+              <a:t>‹#›</a:t>
             </a:fld>
             <a:endParaRPr lang="en-US"/>
           </a:p>
@@ -761,6 +762,214 @@
         <p:cNvPr id="1" name="">
           <a:extLst>
             <a:ext uri="{FF2B5EF4-FFF2-40B4-BE49-F238E27FC236}">
+              <a16:creationId xmlns:a16="http://schemas.microsoft.com/office/drawing/2014/main" id="{35E2CF2A-5A16-AC72-2171-84BCFD345E83}"/>
+            </a:ext>
+          </a:extLst>
+        </p:cNvPr>
+        <p:cNvGrpSpPr/>
+        <p:nvPr/>
+      </p:nvGrpSpPr>
+      <p:grpSpPr>
+        <a:xfrm>
+          <a:off x="0" y="0"/>
+          <a:ext cx="0" cy="0"/>
+          <a:chOff x="0" y="0"/>
+          <a:chExt cx="0" cy="0"/>
+        </a:xfrm>
+      </p:grpSpPr>
+      <p:sp>
+        <p:nvSpPr>
+          <p:cNvPr id="2" name="Espace réservé de l'image des diapositives 1">
+            <a:extLst>
+              <a:ext uri="{FF2B5EF4-FFF2-40B4-BE49-F238E27FC236}">
+                <a16:creationId xmlns:a16="http://schemas.microsoft.com/office/drawing/2014/main" id="{7DE35499-6B5E-DA22-71A5-9ADA33A7F595}"/>
+              </a:ext>
+            </a:extLst>
+          </p:cNvPr>
+          <p:cNvSpPr>
+            <a:spLocks noGrp="1" noRot="1" noChangeAspect="1"/>
+          </p:cNvSpPr>
+          <p:nvPr>
+            <p:ph type="sldImg"/>
+          </p:nvPr>
+        </p:nvSpPr>
+        <p:spPr/>
+      </p:sp>
+      <p:sp>
+        <p:nvSpPr>
+          <p:cNvPr id="3" name="Espace réservé des notes 2">
+            <a:extLst>
+              <a:ext uri="{FF2B5EF4-FFF2-40B4-BE49-F238E27FC236}">
+                <a16:creationId xmlns:a16="http://schemas.microsoft.com/office/drawing/2014/main" id="{86FF6F49-72FE-6080-898E-C01660F20999}"/>
+              </a:ext>
+            </a:extLst>
+          </p:cNvPr>
+          <p:cNvSpPr>
+            <a:spLocks noGrp="1"/>
+          </p:cNvSpPr>
+          <p:nvPr>
+            <p:ph type="body" idx="1"/>
+          </p:nvPr>
+        </p:nvSpPr>
+        <p:spPr/>
+        <p:txBody>
+          <a:bodyPr/>
+          <a:lstStyle/>
+          <a:p>
+            <a:pPr marL="0" marR="0" lvl="0" indent="0" algn="l" defTabSz="914400" rtl="0" eaLnBrk="1" fontAlgn="auto" latinLnBrk="0" hangingPunct="1">
+              <a:lnSpc>
+                <a:spcPct val="100000"/>
+              </a:lnSpc>
+              <a:spcBef>
+                <a:spcPts val="0"/>
+              </a:spcBef>
+              <a:spcAft>
+                <a:spcPts val="0"/>
+              </a:spcAft>
+              <a:buClrTx/>
+              <a:buSzTx/>
+              <a:buFontTx/>
+              <a:buNone/>
+              <a:tabLst/>
+              <a:defRPr/>
+            </a:pPr>
+            <a:r>
+              <a:rPr lang="fr-FR" sz="1200" kern="1200" dirty="0">
+                <a:solidFill>
+                  <a:schemeClr val="tx1"/>
+                </a:solidFill>
+                <a:effectLst/>
+                <a:latin typeface="+mn-lt"/>
+                <a:ea typeface="+mn-ea"/>
+                <a:cs typeface="+mn-cs"/>
+              </a:rPr>
+              <a:t>Déploiement sur </a:t>
+            </a:r>
+            <a:r>
+              <a:rPr lang="fr-FR" sz="1200" kern="1200" dirty="0" err="1">
+                <a:solidFill>
+                  <a:schemeClr val="tx1"/>
+                </a:solidFill>
+                <a:effectLst/>
+                <a:latin typeface="+mn-lt"/>
+                <a:ea typeface="+mn-ea"/>
+                <a:cs typeface="+mn-cs"/>
+              </a:rPr>
+              <a:t>huggingface</a:t>
+            </a:r>
+            <a:r>
+              <a:rPr lang="fr-FR" sz="1200" kern="1200" dirty="0">
+                <a:solidFill>
+                  <a:schemeClr val="tx1"/>
+                </a:solidFill>
+                <a:effectLst/>
+                <a:latin typeface="+mn-lt"/>
+                <a:ea typeface="+mn-ea"/>
+                <a:cs typeface="+mn-cs"/>
+              </a:rPr>
+              <a:t> </a:t>
+            </a:r>
+            <a:r>
+              <a:rPr lang="fr-FR" sz="1200" kern="1200" dirty="0" err="1">
+                <a:solidFill>
+                  <a:schemeClr val="tx1"/>
+                </a:solidFill>
+                <a:effectLst/>
+                <a:latin typeface="+mn-lt"/>
+                <a:ea typeface="+mn-ea"/>
+                <a:cs typeface="+mn-cs"/>
+              </a:rPr>
+              <a:t>spaces</a:t>
+            </a:r>
+            <a:r>
+              <a:rPr lang="fr-FR" sz="1200" kern="1200" dirty="0">
+                <a:solidFill>
+                  <a:schemeClr val="tx1"/>
+                </a:solidFill>
+                <a:effectLst/>
+                <a:latin typeface="+mn-lt"/>
+                <a:ea typeface="+mn-ea"/>
+                <a:cs typeface="+mn-cs"/>
+              </a:rPr>
+              <a:t> =&gt; gestion des secrets et des variables =&gt; pas de BDD =&gt; route déploiement avec utilisation du csv, chemin vers le modèle et le tableau de données gérés comme variables d’environnement dans le repo </a:t>
+            </a:r>
+            <a:r>
+              <a:rPr lang="fr-FR" sz="1200" kern="1200" dirty="0" err="1">
+                <a:solidFill>
+                  <a:schemeClr val="tx1"/>
+                </a:solidFill>
+                <a:effectLst/>
+                <a:latin typeface="+mn-lt"/>
+                <a:ea typeface="+mn-ea"/>
+                <a:cs typeface="+mn-cs"/>
+              </a:rPr>
+              <a:t>space</a:t>
+            </a:r>
+            <a:endParaRPr lang="en-US" sz="1200" kern="1200" dirty="0">
+              <a:solidFill>
+                <a:schemeClr val="tx1"/>
+              </a:solidFill>
+              <a:effectLst/>
+              <a:latin typeface="+mn-lt"/>
+              <a:ea typeface="+mn-ea"/>
+              <a:cs typeface="+mn-cs"/>
+            </a:endParaRPr>
+          </a:p>
+          <a:p>
+            <a:endParaRPr lang="en-US" dirty="0"/>
+          </a:p>
+        </p:txBody>
+      </p:sp>
+      <p:sp>
+        <p:nvSpPr>
+          <p:cNvPr id="4" name="Espace réservé du numéro de diapositive 3">
+            <a:extLst>
+              <a:ext uri="{FF2B5EF4-FFF2-40B4-BE49-F238E27FC236}">
+                <a16:creationId xmlns:a16="http://schemas.microsoft.com/office/drawing/2014/main" id="{F7EC02B4-D0F0-BEFC-E90C-80A495407D28}"/>
+              </a:ext>
+            </a:extLst>
+          </p:cNvPr>
+          <p:cNvSpPr>
+            <a:spLocks noGrp="1"/>
+          </p:cNvSpPr>
+          <p:nvPr>
+            <p:ph type="sldNum" sz="quarter" idx="5"/>
+          </p:nvPr>
+        </p:nvSpPr>
+        <p:spPr/>
+        <p:txBody>
+          <a:bodyPr/>
+          <a:lstStyle/>
+          <a:p>
+            <a:fld id="{A3F3624B-3861-4937-8F64-3EF5A72077AD}" type="slidenum">
+              <a:rPr lang="en-US" smtClean="0"/>
+              <a:t>10</a:t>
+            </a:fld>
+            <a:endParaRPr lang="en-US"/>
+          </a:p>
+        </p:txBody>
+      </p:sp>
+    </p:spTree>
+    <p:extLst>
+      <p:ext uri="{BB962C8B-B14F-4D97-AF65-F5344CB8AC3E}">
+        <p14:creationId xmlns:p14="http://schemas.microsoft.com/office/powerpoint/2010/main" val="922853681"/>
+      </p:ext>
+    </p:extLst>
+  </p:cSld>
+  <p:clrMapOvr>
+    <a:masterClrMapping/>
+  </p:clrMapOvr>
+</p:notes>
+</file>
+
+<file path=ppt/notesSlides/notesSlide11.xml><?xml version="1.0" encoding="utf-8"?>
+<p:notes xmlns:a="http://schemas.openxmlformats.org/drawingml/2006/main" xmlns:r="http://schemas.openxmlformats.org/officeDocument/2006/relationships" xmlns:p="http://schemas.openxmlformats.org/presentationml/2006/main">
+  <p:cSld>
+    <p:spTree>
+      <p:nvGrpSpPr>
+        <p:cNvPr id="1" name="">
+          <a:extLst>
+            <a:ext uri="{FF2B5EF4-FFF2-40B4-BE49-F238E27FC236}">
               <a16:creationId xmlns:a16="http://schemas.microsoft.com/office/drawing/2014/main" id="{E31ECD86-C302-375F-541C-210EC53D81C5}"/>
             </a:ext>
           </a:extLst>
@@ -842,7 +1051,7 @@
           <a:p>
             <a:fld id="{A3F3624B-3861-4937-8F64-3EF5A72077AD}" type="slidenum">
               <a:rPr lang="en-US" smtClean="0"/>
-              <a:t>10</a:t>
+              <a:t>11</a:t>
             </a:fld>
             <a:endParaRPr lang="en-US"/>
           </a:p>
@@ -905,34 +1114,6 @@
           <a:bodyPr/>
           <a:lstStyle/>
           <a:p>
-            <a:r>
-              <a:rPr lang="fr-FR" dirty="0"/>
-              <a:t>Je vais vous présenter les différentes étapes de la mise en place de ce projet en commençant par l’organisation sur </a:t>
-            </a:r>
-            <a:r>
-              <a:rPr lang="fr-FR" dirty="0" err="1"/>
-              <a:t>github</a:t>
-            </a:r>
-            <a:r>
-              <a:rPr lang="fr-FR" dirty="0"/>
-              <a:t> et mon flux de travail avec git. Je passerai ensuite à une démonstration du fonctionnement de l’API lancée sur serveur local, puis je présenterai mon pipeline de CI/CD et le déploiement sur </a:t>
-            </a:r>
-            <a:r>
-              <a:rPr lang="fr-FR" dirty="0" err="1"/>
-              <a:t>HuggingFace</a:t>
-            </a:r>
-            <a:r>
-              <a:rPr lang="fr-FR" dirty="0"/>
-              <a:t> </a:t>
-            </a:r>
-            <a:r>
-              <a:rPr lang="fr-FR" dirty="0" err="1"/>
-              <a:t>spaces</a:t>
-            </a:r>
-            <a:r>
-              <a:rPr lang="fr-FR" dirty="0"/>
-              <a:t> et je finirai par décrire la mise en place de la base de donnée PostgreSQL.</a:t>
-            </a:r>
             <a:endParaRPr lang="en-US" dirty="0"/>
           </a:p>
         </p:txBody>
@@ -1125,10 +1306,6 @@
           <a:bodyPr/>
           <a:lstStyle/>
           <a:p>
-            <a:r>
-              <a:rPr lang="fr-FR" dirty="0"/>
-              <a:t>Donc dans un premier temps voilà ici l’arborescence de mon projet. Le dossier source contient l’API finale, le model au format pickle, les scripts de création de la base de données et les scripts de tests fonctionnels. Il s’agit du projet finalisé dans sa version locale, donc branchée à la base de données. J’ai ensuite un dossier data qui contient </a:t>
-            </a:r>
             <a:endParaRPr lang="en-US" dirty="0"/>
           </a:p>
         </p:txBody>
@@ -1315,106 +1492,6 @@
           <a:bodyPr/>
           <a:lstStyle/>
           <a:p>
-            <a:pPr marL="0" marR="0" lvl="0" indent="0" algn="l" defTabSz="914400" rtl="0" eaLnBrk="1" fontAlgn="auto" latinLnBrk="0" hangingPunct="1">
-              <a:lnSpc>
-                <a:spcPct val="100000"/>
-              </a:lnSpc>
-              <a:spcBef>
-                <a:spcPts val="0"/>
-              </a:spcBef>
-              <a:spcAft>
-                <a:spcPts val="0"/>
-              </a:spcAft>
-              <a:buClrTx/>
-              <a:buSzTx/>
-              <a:buFontTx/>
-              <a:buNone/>
-              <a:tabLst/>
-              <a:defRPr/>
-            </a:pPr>
-            <a:r>
-              <a:rPr lang="fr-FR" sz="1200" kern="1200" dirty="0">
-                <a:solidFill>
-                  <a:schemeClr val="tx1"/>
-                </a:solidFill>
-                <a:effectLst/>
-                <a:latin typeface="+mn-lt"/>
-                <a:ea typeface="+mn-ea"/>
-                <a:cs typeface="+mn-cs"/>
-              </a:rPr>
-              <a:t>Déploiement sur </a:t>
-            </a:r>
-            <a:r>
-              <a:rPr lang="fr-FR" sz="1200" kern="1200" dirty="0" err="1">
-                <a:solidFill>
-                  <a:schemeClr val="tx1"/>
-                </a:solidFill>
-                <a:effectLst/>
-                <a:latin typeface="+mn-lt"/>
-                <a:ea typeface="+mn-ea"/>
-                <a:cs typeface="+mn-cs"/>
-              </a:rPr>
-              <a:t>huggingface</a:t>
-            </a:r>
-            <a:r>
-              <a:rPr lang="fr-FR" sz="1200" kern="1200" dirty="0">
-                <a:solidFill>
-                  <a:schemeClr val="tx1"/>
-                </a:solidFill>
-                <a:effectLst/>
-                <a:latin typeface="+mn-lt"/>
-                <a:ea typeface="+mn-ea"/>
-                <a:cs typeface="+mn-cs"/>
-              </a:rPr>
-              <a:t> </a:t>
-            </a:r>
-            <a:r>
-              <a:rPr lang="fr-FR" sz="1200" kern="1200" dirty="0" err="1">
-                <a:solidFill>
-                  <a:schemeClr val="tx1"/>
-                </a:solidFill>
-                <a:effectLst/>
-                <a:latin typeface="+mn-lt"/>
-                <a:ea typeface="+mn-ea"/>
-                <a:cs typeface="+mn-cs"/>
-              </a:rPr>
-              <a:t>spaces</a:t>
-            </a:r>
-            <a:r>
-              <a:rPr lang="fr-FR" sz="1200" kern="1200" dirty="0">
-                <a:solidFill>
-                  <a:schemeClr val="tx1"/>
-                </a:solidFill>
-                <a:effectLst/>
-                <a:latin typeface="+mn-lt"/>
-                <a:ea typeface="+mn-ea"/>
-                <a:cs typeface="+mn-cs"/>
-              </a:rPr>
-              <a:t> =&gt; gestion des secrets et des variables =&gt; pas de BDD =&gt; route déploiement avec utilisation du csv, chemin vers le modèle et le tableau de données gérés comme variables d’environnement dans le repo </a:t>
-            </a:r>
-            <a:r>
-              <a:rPr lang="fr-FR" sz="1200" kern="1200" dirty="0" err="1">
-                <a:solidFill>
-                  <a:schemeClr val="tx1"/>
-                </a:solidFill>
-                <a:effectLst/>
-                <a:latin typeface="+mn-lt"/>
-                <a:ea typeface="+mn-ea"/>
-                <a:cs typeface="+mn-cs"/>
-              </a:rPr>
-              <a:t>space</a:t>
-            </a:r>
-            <a:endParaRPr lang="en-US" sz="1200" kern="1200" dirty="0">
-              <a:solidFill>
-                <a:schemeClr val="tx1"/>
-              </a:solidFill>
-              <a:effectLst/>
-              <a:latin typeface="+mn-lt"/>
-              <a:ea typeface="+mn-ea"/>
-              <a:cs typeface="+mn-cs"/>
-            </a:endParaRPr>
-          </a:p>
-          <a:p>
             <a:endParaRPr lang="en-US" dirty="0"/>
           </a:p>
         </p:txBody>
@@ -1523,106 +1600,6 @@
           <a:bodyPr/>
           <a:lstStyle/>
           <a:p>
-            <a:pPr marL="0" marR="0" lvl="0" indent="0" algn="l" defTabSz="914400" rtl="0" eaLnBrk="1" fontAlgn="auto" latinLnBrk="0" hangingPunct="1">
-              <a:lnSpc>
-                <a:spcPct val="100000"/>
-              </a:lnSpc>
-              <a:spcBef>
-                <a:spcPts val="0"/>
-              </a:spcBef>
-              <a:spcAft>
-                <a:spcPts val="0"/>
-              </a:spcAft>
-              <a:buClrTx/>
-              <a:buSzTx/>
-              <a:buFontTx/>
-              <a:buNone/>
-              <a:tabLst/>
-              <a:defRPr/>
-            </a:pPr>
-            <a:r>
-              <a:rPr lang="fr-FR" sz="1200" kern="1200" dirty="0">
-                <a:solidFill>
-                  <a:schemeClr val="tx1"/>
-                </a:solidFill>
-                <a:effectLst/>
-                <a:latin typeface="+mn-lt"/>
-                <a:ea typeface="+mn-ea"/>
-                <a:cs typeface="+mn-cs"/>
-              </a:rPr>
-              <a:t>Déploiement sur </a:t>
-            </a:r>
-            <a:r>
-              <a:rPr lang="fr-FR" sz="1200" kern="1200" dirty="0" err="1">
-                <a:solidFill>
-                  <a:schemeClr val="tx1"/>
-                </a:solidFill>
-                <a:effectLst/>
-                <a:latin typeface="+mn-lt"/>
-                <a:ea typeface="+mn-ea"/>
-                <a:cs typeface="+mn-cs"/>
-              </a:rPr>
-              <a:t>huggingface</a:t>
-            </a:r>
-            <a:r>
-              <a:rPr lang="fr-FR" sz="1200" kern="1200" dirty="0">
-                <a:solidFill>
-                  <a:schemeClr val="tx1"/>
-                </a:solidFill>
-                <a:effectLst/>
-                <a:latin typeface="+mn-lt"/>
-                <a:ea typeface="+mn-ea"/>
-                <a:cs typeface="+mn-cs"/>
-              </a:rPr>
-              <a:t> </a:t>
-            </a:r>
-            <a:r>
-              <a:rPr lang="fr-FR" sz="1200" kern="1200" dirty="0" err="1">
-                <a:solidFill>
-                  <a:schemeClr val="tx1"/>
-                </a:solidFill>
-                <a:effectLst/>
-                <a:latin typeface="+mn-lt"/>
-                <a:ea typeface="+mn-ea"/>
-                <a:cs typeface="+mn-cs"/>
-              </a:rPr>
-              <a:t>spaces</a:t>
-            </a:r>
-            <a:r>
-              <a:rPr lang="fr-FR" sz="1200" kern="1200" dirty="0">
-                <a:solidFill>
-                  <a:schemeClr val="tx1"/>
-                </a:solidFill>
-                <a:effectLst/>
-                <a:latin typeface="+mn-lt"/>
-                <a:ea typeface="+mn-ea"/>
-                <a:cs typeface="+mn-cs"/>
-              </a:rPr>
-              <a:t> =&gt; gestion des secrets et des variables =&gt; pas de BDD =&gt; route déploiement avec utilisation du csv, chemin vers le modèle et le tableau de données gérés comme variables d’environnement dans le repo </a:t>
-            </a:r>
-            <a:r>
-              <a:rPr lang="fr-FR" sz="1200" kern="1200" dirty="0" err="1">
-                <a:solidFill>
-                  <a:schemeClr val="tx1"/>
-                </a:solidFill>
-                <a:effectLst/>
-                <a:latin typeface="+mn-lt"/>
-                <a:ea typeface="+mn-ea"/>
-                <a:cs typeface="+mn-cs"/>
-              </a:rPr>
-              <a:t>space</a:t>
-            </a:r>
-            <a:endParaRPr lang="en-US" sz="1200" kern="1200" dirty="0">
-              <a:solidFill>
-                <a:schemeClr val="tx1"/>
-              </a:solidFill>
-              <a:effectLst/>
-              <a:latin typeface="+mn-lt"/>
-              <a:ea typeface="+mn-ea"/>
-              <a:cs typeface="+mn-cs"/>
-            </a:endParaRPr>
-          </a:p>
-          <a:p>
             <a:endParaRPr lang="en-US" dirty="0"/>
           </a:p>
         </p:txBody>
@@ -1731,106 +1708,6 @@
           <a:bodyPr/>
           <a:lstStyle/>
           <a:p>
-            <a:pPr marL="0" marR="0" lvl="0" indent="0" algn="l" defTabSz="914400" rtl="0" eaLnBrk="1" fontAlgn="auto" latinLnBrk="0" hangingPunct="1">
-              <a:lnSpc>
-                <a:spcPct val="100000"/>
-              </a:lnSpc>
-              <a:spcBef>
-                <a:spcPts val="0"/>
-              </a:spcBef>
-              <a:spcAft>
-                <a:spcPts val="0"/>
-              </a:spcAft>
-              <a:buClrTx/>
-              <a:buSzTx/>
-              <a:buFontTx/>
-              <a:buNone/>
-              <a:tabLst/>
-              <a:defRPr/>
-            </a:pPr>
-            <a:r>
-              <a:rPr lang="fr-FR" sz="1200" kern="1200" dirty="0">
-                <a:solidFill>
-                  <a:schemeClr val="tx1"/>
-                </a:solidFill>
-                <a:effectLst/>
-                <a:latin typeface="+mn-lt"/>
-                <a:ea typeface="+mn-ea"/>
-                <a:cs typeface="+mn-cs"/>
-              </a:rPr>
-              <a:t>Déploiement sur </a:t>
-            </a:r>
-            <a:r>
-              <a:rPr lang="fr-FR" sz="1200" kern="1200" dirty="0" err="1">
-                <a:solidFill>
-                  <a:schemeClr val="tx1"/>
-                </a:solidFill>
-                <a:effectLst/>
-                <a:latin typeface="+mn-lt"/>
-                <a:ea typeface="+mn-ea"/>
-                <a:cs typeface="+mn-cs"/>
-              </a:rPr>
-              <a:t>huggingface</a:t>
-            </a:r>
-            <a:r>
-              <a:rPr lang="fr-FR" sz="1200" kern="1200" dirty="0">
-                <a:solidFill>
-                  <a:schemeClr val="tx1"/>
-                </a:solidFill>
-                <a:effectLst/>
-                <a:latin typeface="+mn-lt"/>
-                <a:ea typeface="+mn-ea"/>
-                <a:cs typeface="+mn-cs"/>
-              </a:rPr>
-              <a:t> </a:t>
-            </a:r>
-            <a:r>
-              <a:rPr lang="fr-FR" sz="1200" kern="1200" dirty="0" err="1">
-                <a:solidFill>
-                  <a:schemeClr val="tx1"/>
-                </a:solidFill>
-                <a:effectLst/>
-                <a:latin typeface="+mn-lt"/>
-                <a:ea typeface="+mn-ea"/>
-                <a:cs typeface="+mn-cs"/>
-              </a:rPr>
-              <a:t>spaces</a:t>
-            </a:r>
-            <a:r>
-              <a:rPr lang="fr-FR" sz="1200" kern="1200" dirty="0">
-                <a:solidFill>
-                  <a:schemeClr val="tx1"/>
-                </a:solidFill>
-                <a:effectLst/>
-                <a:latin typeface="+mn-lt"/>
-                <a:ea typeface="+mn-ea"/>
-                <a:cs typeface="+mn-cs"/>
-              </a:rPr>
-              <a:t> =&gt; gestion des secrets et des variables =&gt; pas de BDD =&gt; route déploiement avec utilisation du csv, chemin vers le modèle et le tableau de données gérés comme variables d’environnement dans le repo </a:t>
-            </a:r>
-            <a:r>
-              <a:rPr lang="fr-FR" sz="1200" kern="1200" dirty="0" err="1">
-                <a:solidFill>
-                  <a:schemeClr val="tx1"/>
-                </a:solidFill>
-                <a:effectLst/>
-                <a:latin typeface="+mn-lt"/>
-                <a:ea typeface="+mn-ea"/>
-                <a:cs typeface="+mn-cs"/>
-              </a:rPr>
-              <a:t>space</a:t>
-            </a:r>
-            <a:endParaRPr lang="en-US" sz="1200" kern="1200" dirty="0">
-              <a:solidFill>
-                <a:schemeClr val="tx1"/>
-              </a:solidFill>
-              <a:effectLst/>
-              <a:latin typeface="+mn-lt"/>
-              <a:ea typeface="+mn-ea"/>
-              <a:cs typeface="+mn-cs"/>
-            </a:endParaRPr>
-          </a:p>
-          <a:p>
             <a:endParaRPr lang="en-US" dirty="0"/>
           </a:p>
         </p:txBody>
@@ -1885,7 +1762,7 @@
         <p:cNvPr id="1" name="">
           <a:extLst>
             <a:ext uri="{FF2B5EF4-FFF2-40B4-BE49-F238E27FC236}">
-              <a16:creationId xmlns:a16="http://schemas.microsoft.com/office/drawing/2014/main" id="{35E2CF2A-5A16-AC72-2171-84BCFD345E83}"/>
+              <a16:creationId xmlns:a16="http://schemas.microsoft.com/office/drawing/2014/main" id="{395FA266-E108-62A8-1EDA-D8BD8B7B7900}"/>
             </a:ext>
           </a:extLst>
         </p:cNvPr>
@@ -1905,7 +1782,7 @@
           <p:cNvPr id="2" name="Espace réservé de l'image des diapositives 1">
             <a:extLst>
               <a:ext uri="{FF2B5EF4-FFF2-40B4-BE49-F238E27FC236}">
-                <a16:creationId xmlns:a16="http://schemas.microsoft.com/office/drawing/2014/main" id="{7DE35499-6B5E-DA22-71A5-9ADA33A7F595}"/>
+                <a16:creationId xmlns:a16="http://schemas.microsoft.com/office/drawing/2014/main" id="{0707F50A-85BE-6279-241D-DFB5D39CF2AF}"/>
               </a:ext>
             </a:extLst>
           </p:cNvPr>
@@ -1923,7 +1800,7 @@
           <p:cNvPr id="3" name="Espace réservé des notes 2">
             <a:extLst>
               <a:ext uri="{FF2B5EF4-FFF2-40B4-BE49-F238E27FC236}">
-                <a16:creationId xmlns:a16="http://schemas.microsoft.com/office/drawing/2014/main" id="{86FF6F49-72FE-6080-898E-C01660F20999}"/>
+                <a16:creationId xmlns:a16="http://schemas.microsoft.com/office/drawing/2014/main" id="{05DA60D6-5998-FD94-94CE-CBA986BE5DDF}"/>
               </a:ext>
             </a:extLst>
           </p:cNvPr>
@@ -1939,106 +1816,6 @@
           <a:bodyPr/>
           <a:lstStyle/>
           <a:p>
-            <a:pPr marL="0" marR="0" lvl="0" indent="0" algn="l" defTabSz="914400" rtl="0" eaLnBrk="1" fontAlgn="auto" latinLnBrk="0" hangingPunct="1">
-              <a:lnSpc>
-                <a:spcPct val="100000"/>
-              </a:lnSpc>
-              <a:spcBef>
-                <a:spcPts val="0"/>
-              </a:spcBef>
-              <a:spcAft>
-                <a:spcPts val="0"/>
-              </a:spcAft>
-              <a:buClrTx/>
-              <a:buSzTx/>
-              <a:buFontTx/>
-              <a:buNone/>
-              <a:tabLst/>
-              <a:defRPr/>
-            </a:pPr>
-            <a:r>
-              <a:rPr lang="fr-FR" sz="1200" kern="1200" dirty="0">
-                <a:solidFill>
-                  <a:schemeClr val="tx1"/>
-                </a:solidFill>
-                <a:effectLst/>
-                <a:latin typeface="+mn-lt"/>
-                <a:ea typeface="+mn-ea"/>
-                <a:cs typeface="+mn-cs"/>
-              </a:rPr>
-              <a:t>Déploiement sur </a:t>
-            </a:r>
-            <a:r>
-              <a:rPr lang="fr-FR" sz="1200" kern="1200" dirty="0" err="1">
-                <a:solidFill>
-                  <a:schemeClr val="tx1"/>
-                </a:solidFill>
-                <a:effectLst/>
-                <a:latin typeface="+mn-lt"/>
-                <a:ea typeface="+mn-ea"/>
-                <a:cs typeface="+mn-cs"/>
-              </a:rPr>
-              <a:t>huggingface</a:t>
-            </a:r>
-            <a:r>
-              <a:rPr lang="fr-FR" sz="1200" kern="1200" dirty="0">
-                <a:solidFill>
-                  <a:schemeClr val="tx1"/>
-                </a:solidFill>
-                <a:effectLst/>
-                <a:latin typeface="+mn-lt"/>
-                <a:ea typeface="+mn-ea"/>
-                <a:cs typeface="+mn-cs"/>
-              </a:rPr>
-              <a:t> </a:t>
-            </a:r>
-            <a:r>
-              <a:rPr lang="fr-FR" sz="1200" kern="1200" dirty="0" err="1">
-                <a:solidFill>
-                  <a:schemeClr val="tx1"/>
-                </a:solidFill>
-                <a:effectLst/>
-                <a:latin typeface="+mn-lt"/>
-                <a:ea typeface="+mn-ea"/>
-                <a:cs typeface="+mn-cs"/>
-              </a:rPr>
-              <a:t>spaces</a:t>
-            </a:r>
-            <a:r>
-              <a:rPr lang="fr-FR" sz="1200" kern="1200" dirty="0">
-                <a:solidFill>
-                  <a:schemeClr val="tx1"/>
-                </a:solidFill>
-                <a:effectLst/>
-                <a:latin typeface="+mn-lt"/>
-                <a:ea typeface="+mn-ea"/>
-                <a:cs typeface="+mn-cs"/>
-              </a:rPr>
-              <a:t> =&gt; gestion des secrets et des variables =&gt; pas de BDD =&gt; route déploiement avec utilisation du csv, chemin vers le modèle et le tableau de données gérés comme variables d’environnement dans le repo </a:t>
-            </a:r>
-            <a:r>
-              <a:rPr lang="fr-FR" sz="1200" kern="1200" dirty="0" err="1">
-                <a:solidFill>
-                  <a:schemeClr val="tx1"/>
-                </a:solidFill>
-                <a:effectLst/>
-                <a:latin typeface="+mn-lt"/>
-                <a:ea typeface="+mn-ea"/>
-                <a:cs typeface="+mn-cs"/>
-              </a:rPr>
-              <a:t>space</a:t>
-            </a:r>
-            <a:endParaRPr lang="en-US" sz="1200" kern="1200" dirty="0">
-              <a:solidFill>
-                <a:schemeClr val="tx1"/>
-              </a:solidFill>
-              <a:effectLst/>
-              <a:latin typeface="+mn-lt"/>
-              <a:ea typeface="+mn-ea"/>
-              <a:cs typeface="+mn-cs"/>
-            </a:endParaRPr>
-          </a:p>
-          <a:p>
             <a:endParaRPr lang="en-US" dirty="0"/>
           </a:p>
         </p:txBody>
@@ -2048,7 +1825,7 @@
           <p:cNvPr id="4" name="Espace réservé du numéro de diapositive 3">
             <a:extLst>
               <a:ext uri="{FF2B5EF4-FFF2-40B4-BE49-F238E27FC236}">
-                <a16:creationId xmlns:a16="http://schemas.microsoft.com/office/drawing/2014/main" id="{F7EC02B4-D0F0-BEFC-E90C-80A495407D28}"/>
+                <a16:creationId xmlns:a16="http://schemas.microsoft.com/office/drawing/2014/main" id="{8A3E5E52-DB51-B011-C68C-E1E48834DED2}"/>
               </a:ext>
             </a:extLst>
           </p:cNvPr>
@@ -2075,7 +1852,7 @@
     </p:spTree>
     <p:extLst>
       <p:ext uri="{BB962C8B-B14F-4D97-AF65-F5344CB8AC3E}">
-        <p14:creationId xmlns:p14="http://schemas.microsoft.com/office/powerpoint/2010/main" val="922853681"/>
+        <p14:creationId xmlns:p14="http://schemas.microsoft.com/office/powerpoint/2010/main" val="452167461"/>
       </p:ext>
     </p:extLst>
   </p:cSld>
@@ -2373,7 +2150,7 @@
           <a:p>
             <a:fld id="{D1F3894F-03A6-4760-8AFF-8C8908CB964C}" type="datetimeFigureOut">
               <a:rPr lang="en-US" smtClean="0"/>
-              <a:t>8/14/2026</a:t>
+              <a:t>8/17/2026</a:t>
             </a:fld>
             <a:endParaRPr lang="en-US"/>
           </a:p>
@@ -2420,7 +2197,7 @@
           <a:p>
             <a:fld id="{6D22F896-40B5-4ADD-8801-0D06FADFA095}" type="slidenum">
               <a:rPr lang="en-US" dirty="0"/>
-              <a:t>‹N°›</a:t>
+              <a:t>‹#›</a:t>
             </a:fld>
             <a:endParaRPr lang="en-US" dirty="0"/>
           </a:p>
@@ -2787,7 +2564,7 @@
           <a:p>
             <a:fld id="{D1F3894F-03A6-4760-8AFF-8C8908CB964C}" type="datetimeFigureOut">
               <a:rPr lang="en-US" smtClean="0"/>
-              <a:t>8/14/2026</a:t>
+              <a:t>8/17/2026</a:t>
             </a:fld>
             <a:endParaRPr lang="en-US"/>
           </a:p>
@@ -2834,7 +2611,7 @@
           <a:p>
             <a:fld id="{DD68962E-EF79-4265-AC71-696A4F49210D}" type="slidenum">
               <a:rPr lang="en-US" smtClean="0"/>
-              <a:t>‹N°›</a:t>
+              <a:t>‹#›</a:t>
             </a:fld>
             <a:endParaRPr lang="en-US" dirty="0"/>
           </a:p>
@@ -3123,7 +2900,7 @@
           <a:p>
             <a:fld id="{D1F3894F-03A6-4760-8AFF-8C8908CB964C}" type="datetimeFigureOut">
               <a:rPr lang="en-US" smtClean="0"/>
-              <a:t>8/14/2026</a:t>
+              <a:t>8/17/2026</a:t>
             </a:fld>
             <a:endParaRPr lang="en-US"/>
           </a:p>
@@ -3170,7 +2947,7 @@
           <a:p>
             <a:fld id="{DD68962E-EF79-4265-AC71-696A4F49210D}" type="slidenum">
               <a:rPr lang="en-US" smtClean="0"/>
-              <a:t>‹N°›</a:t>
+              <a:t>‹#›</a:t>
             </a:fld>
             <a:endParaRPr lang="en-US" dirty="0"/>
           </a:p>
@@ -3528,7 +3305,7 @@
           <a:p>
             <a:fld id="{D1F3894F-03A6-4760-8AFF-8C8908CB964C}" type="datetimeFigureOut">
               <a:rPr lang="en-US" smtClean="0"/>
-              <a:t>8/14/2026</a:t>
+              <a:t>8/17/2026</a:t>
             </a:fld>
             <a:endParaRPr lang="en-US"/>
           </a:p>
@@ -3575,7 +3352,7 @@
           <a:p>
             <a:fld id="{DD68962E-EF79-4265-AC71-696A4F49210D}" type="slidenum">
               <a:rPr lang="en-US" smtClean="0"/>
-              <a:t>‹N°›</a:t>
+              <a:t>‹#›</a:t>
             </a:fld>
             <a:endParaRPr lang="en-US" dirty="0"/>
           </a:p>
@@ -4096,7 +3873,7 @@
           <a:p>
             <a:fld id="{D1F3894F-03A6-4760-8AFF-8C8908CB964C}" type="datetimeFigureOut">
               <a:rPr lang="en-US" smtClean="0"/>
-              <a:t>8/14/2026</a:t>
+              <a:t>8/17/2026</a:t>
             </a:fld>
             <a:endParaRPr lang="en-US"/>
           </a:p>
@@ -4143,7 +3920,7 @@
           <a:p>
             <a:fld id="{DD68962E-EF79-4265-AC71-696A4F49210D}" type="slidenum">
               <a:rPr lang="en-US" smtClean="0"/>
-              <a:t>‹N°›</a:t>
+              <a:t>‹#›</a:t>
             </a:fld>
             <a:endParaRPr lang="en-US"/>
           </a:p>
@@ -4777,7 +4554,7 @@
           <a:p>
             <a:fld id="{D1F3894F-03A6-4760-8AFF-8C8908CB964C}" type="datetimeFigureOut">
               <a:rPr lang="en-US" smtClean="0"/>
-              <a:t>8/14/2026</a:t>
+              <a:t>8/17/2026</a:t>
             </a:fld>
             <a:endParaRPr lang="en-US"/>
           </a:p>
@@ -4819,7 +4596,7 @@
           <a:p>
             <a:fld id="{DD68962E-EF79-4265-AC71-696A4F49210D}" type="slidenum">
               <a:rPr lang="en-US" smtClean="0"/>
-              <a:t>‹N°›</a:t>
+              <a:t>‹#›</a:t>
             </a:fld>
             <a:endParaRPr lang="en-US" dirty="0"/>
           </a:p>
@@ -5690,7 +5467,7 @@
           <a:p>
             <a:fld id="{D1F3894F-03A6-4760-8AFF-8C8908CB964C}" type="datetimeFigureOut">
               <a:rPr lang="en-US" smtClean="0"/>
-              <a:t>8/14/2026</a:t>
+              <a:t>8/17/2026</a:t>
             </a:fld>
             <a:endParaRPr lang="en-US"/>
           </a:p>
@@ -5732,7 +5509,7 @@
           <a:p>
             <a:fld id="{DD68962E-EF79-4265-AC71-696A4F49210D}" type="slidenum">
               <a:rPr lang="en-US" smtClean="0"/>
-              <a:t>‹N°›</a:t>
+              <a:t>‹#›</a:t>
             </a:fld>
             <a:endParaRPr lang="en-US" dirty="0"/>
           </a:p>
@@ -6003,7 +5780,7 @@
           <a:p>
             <a:fld id="{D1F3894F-03A6-4760-8AFF-8C8908CB964C}" type="datetimeFigureOut">
               <a:rPr lang="en-US" smtClean="0"/>
-              <a:t>8/14/2026</a:t>
+              <a:t>8/17/2026</a:t>
             </a:fld>
             <a:endParaRPr lang="en-US"/>
           </a:p>
@@ -6045,7 +5822,7 @@
           <a:p>
             <a:fld id="{DD68962E-EF79-4265-AC71-696A4F49210D}" type="slidenum">
               <a:rPr lang="en-US" smtClean="0"/>
-              <a:t>‹N°›</a:t>
+              <a:t>‹#›</a:t>
             </a:fld>
             <a:endParaRPr lang="en-US"/>
           </a:p>
@@ -6267,7 +6044,7 @@
           <a:p>
             <a:fld id="{D1F3894F-03A6-4760-8AFF-8C8908CB964C}" type="datetimeFigureOut">
               <a:rPr lang="en-US" smtClean="0"/>
-              <a:t>8/14/2026</a:t>
+              <a:t>8/17/2026</a:t>
             </a:fld>
             <a:endParaRPr lang="en-US"/>
           </a:p>
@@ -6323,7 +6100,7 @@
           <a:p>
             <a:fld id="{DD68962E-EF79-4265-AC71-696A4F49210D}" type="slidenum">
               <a:rPr lang="en-US" smtClean="0"/>
-              <a:t>‹N°›</a:t>
+              <a:t>‹#›</a:t>
             </a:fld>
             <a:endParaRPr lang="en-US"/>
           </a:p>
@@ -6461,7 +6238,7 @@
           <a:p>
             <a:fld id="{D1F3894F-03A6-4760-8AFF-8C8908CB964C}" type="datetimeFigureOut">
               <a:rPr lang="en-US" smtClean="0"/>
-              <a:t>8/14/2026</a:t>
+              <a:t>8/17/2026</a:t>
             </a:fld>
             <a:endParaRPr lang="en-US"/>
           </a:p>
@@ -6761,7 +6538,7 @@
           <a:p>
             <a:fld id="{D1F3894F-03A6-4760-8AFF-8C8908CB964C}" type="datetimeFigureOut">
               <a:rPr lang="en-US" smtClean="0"/>
-              <a:t>8/14/2026</a:t>
+              <a:t>8/17/2026</a:t>
             </a:fld>
             <a:endParaRPr lang="en-US"/>
           </a:p>
@@ -6803,7 +6580,7 @@
           <a:p>
             <a:fld id="{6D22F896-40B5-4ADD-8801-0D06FADFA095}" type="slidenum">
               <a:rPr lang="en-US" dirty="0"/>
-              <a:t>‹N°›</a:t>
+              <a:t>‹#›</a:t>
             </a:fld>
             <a:endParaRPr lang="en-US" dirty="0"/>
           </a:p>
@@ -7150,7 +6927,7 @@
           <a:p>
             <a:fld id="{D1F3894F-03A6-4760-8AFF-8C8908CB964C}" type="datetimeFigureOut">
               <a:rPr lang="en-US" smtClean="0"/>
-              <a:t>8/14/2026</a:t>
+              <a:t>8/17/2026</a:t>
             </a:fld>
             <a:endParaRPr lang="en-US"/>
           </a:p>
@@ -7197,7 +6974,7 @@
           <a:p>
             <a:fld id="{DD68962E-EF79-4265-AC71-696A4F49210D}" type="slidenum">
               <a:rPr lang="en-US" smtClean="0"/>
-              <a:t>‹N°›</a:t>
+              <a:t>‹#›</a:t>
             </a:fld>
             <a:endParaRPr lang="en-US" dirty="0"/>
           </a:p>
@@ -7526,7 +7303,7 @@
           <a:p>
             <a:fld id="{D1F3894F-03A6-4760-8AFF-8C8908CB964C}" type="datetimeFigureOut">
               <a:rPr lang="en-US" smtClean="0"/>
-              <a:t>8/14/2026</a:t>
+              <a:t>8/17/2026</a:t>
             </a:fld>
             <a:endParaRPr lang="en-US"/>
           </a:p>
@@ -7568,7 +7345,7 @@
           <a:p>
             <a:fld id="{DD68962E-EF79-4265-AC71-696A4F49210D}" type="slidenum">
               <a:rPr lang="en-US" smtClean="0"/>
-              <a:t>‹N°›</a:t>
+              <a:t>‹#›</a:t>
             </a:fld>
             <a:endParaRPr lang="en-US"/>
           </a:p>
@@ -8120,7 +7897,7 @@
           <a:p>
             <a:fld id="{D1F3894F-03A6-4760-8AFF-8C8908CB964C}" type="datetimeFigureOut">
               <a:rPr lang="en-US" smtClean="0"/>
-              <a:t>8/14/2026</a:t>
+              <a:t>8/17/2026</a:t>
             </a:fld>
             <a:endParaRPr lang="en-US"/>
           </a:p>
@@ -8162,7 +7939,7 @@
           <a:p>
             <a:fld id="{DD68962E-EF79-4265-AC71-696A4F49210D}" type="slidenum">
               <a:rPr lang="en-US" smtClean="0"/>
-              <a:t>‹N°›</a:t>
+              <a:t>‹#›</a:t>
             </a:fld>
             <a:endParaRPr lang="en-US"/>
           </a:p>
@@ -8465,7 +8242,7 @@
           <a:p>
             <a:fld id="{D1F3894F-03A6-4760-8AFF-8C8908CB964C}" type="datetimeFigureOut">
               <a:rPr lang="en-US" smtClean="0"/>
-              <a:t>8/14/2026</a:t>
+              <a:t>8/17/2026</a:t>
             </a:fld>
             <a:endParaRPr lang="en-US"/>
           </a:p>
@@ -8507,7 +8284,7 @@
           <a:p>
             <a:fld id="{DD68962E-EF79-4265-AC71-696A4F49210D}" type="slidenum">
               <a:rPr lang="en-US" smtClean="0"/>
-              <a:t>‹N°›</a:t>
+              <a:t>‹#›</a:t>
             </a:fld>
             <a:endParaRPr lang="en-US"/>
           </a:p>
@@ -8716,7 +8493,7 @@
           <a:p>
             <a:fld id="{D1F3894F-03A6-4760-8AFF-8C8908CB964C}" type="datetimeFigureOut">
               <a:rPr lang="en-US" smtClean="0"/>
-              <a:t>8/14/2026</a:t>
+              <a:t>8/17/2026</a:t>
             </a:fld>
             <a:endParaRPr lang="en-US"/>
           </a:p>
@@ -8758,7 +8535,7 @@
           <a:p>
             <a:fld id="{DD68962E-EF79-4265-AC71-696A4F49210D}" type="slidenum">
               <a:rPr lang="en-US" smtClean="0"/>
-              <a:t>‹N°›</a:t>
+              <a:t>‹#›</a:t>
             </a:fld>
             <a:endParaRPr lang="en-US"/>
           </a:p>
@@ -9194,7 +8971,7 @@
           <a:p>
             <a:fld id="{D1F3894F-03A6-4760-8AFF-8C8908CB964C}" type="datetimeFigureOut">
               <a:rPr lang="en-US" smtClean="0"/>
-              <a:t>8/14/2026</a:t>
+              <a:t>8/17/2026</a:t>
             </a:fld>
             <a:endParaRPr lang="en-US"/>
           </a:p>
@@ -9236,7 +9013,7 @@
           <a:p>
             <a:fld id="{DD68962E-EF79-4265-AC71-696A4F49210D}" type="slidenum">
               <a:rPr lang="en-US" smtClean="0"/>
-              <a:t>‹N°›</a:t>
+              <a:t>‹#›</a:t>
             </a:fld>
             <a:endParaRPr lang="en-US"/>
           </a:p>
@@ -9603,7 +9380,7 @@
           <a:p>
             <a:fld id="{D1F3894F-03A6-4760-8AFF-8C8908CB964C}" type="datetimeFigureOut">
               <a:rPr lang="en-US" smtClean="0"/>
-              <a:t>8/14/2026</a:t>
+              <a:t>8/17/2026</a:t>
             </a:fld>
             <a:endParaRPr lang="en-US"/>
           </a:p>
@@ -9645,7 +9422,7 @@
           <a:p>
             <a:fld id="{DD68962E-EF79-4265-AC71-696A4F49210D}" type="slidenum">
               <a:rPr lang="en-US" smtClean="0"/>
-              <a:t>‹N°›</a:t>
+              <a:t>‹#›</a:t>
             </a:fld>
             <a:endParaRPr lang="en-US"/>
           </a:p>
@@ -9847,7 +9624,7 @@
           <a:p>
             <a:fld id="{D1F3894F-03A6-4760-8AFF-8C8908CB964C}" type="datetimeFigureOut">
               <a:rPr lang="en-US" smtClean="0"/>
-              <a:t>8/14/2026</a:t>
+              <a:t>8/17/2026</a:t>
             </a:fld>
             <a:endParaRPr lang="en-US"/>
           </a:p>
@@ -9925,7 +9702,7 @@
           <a:p>
             <a:fld id="{DD68962E-EF79-4265-AC71-696A4F49210D}" type="slidenum">
               <a:rPr lang="en-US" smtClean="0"/>
-              <a:t>‹N°›</a:t>
+              <a:t>‹#›</a:t>
             </a:fld>
             <a:endParaRPr lang="en-US" dirty="0"/>
           </a:p>
@@ -10446,6 +10223,431 @@
         <p:cNvPr id="1" name="">
           <a:extLst>
             <a:ext uri="{FF2B5EF4-FFF2-40B4-BE49-F238E27FC236}">
+              <a16:creationId xmlns:a16="http://schemas.microsoft.com/office/drawing/2014/main" id="{AF761774-17B2-316B-B5E3-C8ECC654D36E}"/>
+            </a:ext>
+          </a:extLst>
+        </p:cNvPr>
+        <p:cNvGrpSpPr/>
+        <p:nvPr/>
+      </p:nvGrpSpPr>
+      <p:grpSpPr>
+        <a:xfrm>
+          <a:off x="0" y="0"/>
+          <a:ext cx="0" cy="0"/>
+          <a:chOff x="0" y="0"/>
+          <a:chExt cx="0" cy="0"/>
+        </a:xfrm>
+      </p:grpSpPr>
+      <p:sp>
+        <p:nvSpPr>
+          <p:cNvPr id="5" name="ZoneTexte 4">
+            <a:extLst>
+              <a:ext uri="{FF2B5EF4-FFF2-40B4-BE49-F238E27FC236}">
+                <a16:creationId xmlns:a16="http://schemas.microsoft.com/office/drawing/2014/main" id="{3894094E-56AD-D7E0-BF48-63B4518BF1FC}"/>
+              </a:ext>
+            </a:extLst>
+          </p:cNvPr>
+          <p:cNvSpPr txBox="1"/>
+          <p:nvPr/>
+        </p:nvSpPr>
+        <p:spPr>
+          <a:xfrm>
+            <a:off x="381600" y="632143"/>
+            <a:ext cx="10012466" cy="1323439"/>
+          </a:xfrm>
+          <a:prstGeom prst="rect">
+            <a:avLst/>
+          </a:prstGeom>
+          <a:noFill/>
+        </p:spPr>
+        <p:txBody>
+          <a:bodyPr wrap="square" rtlCol="0">
+            <a:spAutoFit/>
+          </a:bodyPr>
+          <a:lstStyle/>
+          <a:p>
+            <a:r>
+              <a:rPr lang="fr-FR" sz="4000" dirty="0">
+                <a:latin typeface="Eras Demi ITC" panose="020B0805030504020804" pitchFamily="34" charset="0"/>
+              </a:rPr>
+              <a:t>III</a:t>
+            </a:r>
+            <a:r>
+              <a:rPr lang="fr-FR" sz="4000" noProof="0" dirty="0">
+                <a:latin typeface="Eras Demi ITC" panose="020B0805030504020804" pitchFamily="34" charset="0"/>
+              </a:rPr>
+              <a:t>. Résultats du monitoring et optimisation</a:t>
+            </a:r>
+          </a:p>
+        </p:txBody>
+      </p:sp>
+      <p:pic>
+        <p:nvPicPr>
+          <p:cNvPr id="3" name="Image 2">
+            <a:extLst>
+              <a:ext uri="{FF2B5EF4-FFF2-40B4-BE49-F238E27FC236}">
+                <a16:creationId xmlns:a16="http://schemas.microsoft.com/office/drawing/2014/main" id="{4779BAFB-8C55-6147-EDE8-D3C1F8FF0C89}"/>
+              </a:ext>
+            </a:extLst>
+          </p:cNvPr>
+          <p:cNvPicPr>
+            <a:picLocks noChangeAspect="1"/>
+          </p:cNvPicPr>
+          <p:nvPr/>
+        </p:nvPicPr>
+        <p:blipFill>
+          <a:blip r:embed="rId3">
+            <a:extLst>
+              <a:ext uri="{28A0092B-C50C-407E-A947-70E740481C1C}">
+                <a14:useLocalDpi xmlns:a14="http://schemas.microsoft.com/office/drawing/2010/main" val="0"/>
+              </a:ext>
+            </a:extLst>
+          </a:blip>
+          <a:srcRect l="21309" t="47" r="33259" b="59326"/>
+          <a:stretch>
+            <a:fillRect/>
+          </a:stretch>
+        </p:blipFill>
+        <p:spPr>
+          <a:xfrm>
+            <a:off x="5553307" y="2165176"/>
+            <a:ext cx="6393268" cy="4255944"/>
+          </a:xfrm>
+          <a:prstGeom prst="rect">
+            <a:avLst/>
+          </a:prstGeom>
+        </p:spPr>
+      </p:pic>
+      <p:sp>
+        <p:nvSpPr>
+          <p:cNvPr id="8" name="ZoneTexte 7">
+            <a:extLst>
+              <a:ext uri="{FF2B5EF4-FFF2-40B4-BE49-F238E27FC236}">
+                <a16:creationId xmlns:a16="http://schemas.microsoft.com/office/drawing/2014/main" id="{B94ACE82-35E3-E7B1-A889-4608302337A5}"/>
+              </a:ext>
+            </a:extLst>
+          </p:cNvPr>
+          <p:cNvSpPr txBox="1"/>
+          <p:nvPr/>
+        </p:nvSpPr>
+        <p:spPr>
+          <a:xfrm>
+            <a:off x="167718" y="2076886"/>
+            <a:ext cx="5796202" cy="584775"/>
+          </a:xfrm>
+          <a:prstGeom prst="rect">
+            <a:avLst/>
+          </a:prstGeom>
+          <a:noFill/>
+          <a:ln>
+            <a:noFill/>
+          </a:ln>
+        </p:spPr>
+        <p:txBody>
+          <a:bodyPr wrap="square" rtlCol="0">
+            <a:spAutoFit/>
+          </a:bodyPr>
+          <a:lstStyle/>
+          <a:p>
+            <a:r>
+              <a:rPr lang="fr-FR" sz="3200" b="1" noProof="0" dirty="0">
+                <a:ea typeface="Microsoft JhengHei UI" panose="020B0604030504040204" pitchFamily="34" charset="-120"/>
+              </a:rPr>
+              <a:t>Optimisation du modèle :</a:t>
+            </a:r>
+            <a:endParaRPr lang="fr-FR" sz="3200" i="1" noProof="0" dirty="0">
+              <a:ea typeface="Microsoft JhengHei UI Light" panose="020B0304030504040204" pitchFamily="34" charset="-120"/>
+            </a:endParaRPr>
+          </a:p>
+        </p:txBody>
+      </p:sp>
+      <p:sp>
+        <p:nvSpPr>
+          <p:cNvPr id="15" name="ZoneTexte 14">
+            <a:extLst>
+              <a:ext uri="{FF2B5EF4-FFF2-40B4-BE49-F238E27FC236}">
+                <a16:creationId xmlns:a16="http://schemas.microsoft.com/office/drawing/2014/main" id="{31995DC8-B439-6522-91A7-8AD4E4F1C465}"/>
+              </a:ext>
+            </a:extLst>
+          </p:cNvPr>
+          <p:cNvSpPr txBox="1"/>
+          <p:nvPr/>
+        </p:nvSpPr>
+        <p:spPr>
+          <a:xfrm>
+            <a:off x="251709" y="2490577"/>
+            <a:ext cx="4911306" cy="584775"/>
+          </a:xfrm>
+          <a:prstGeom prst="rect">
+            <a:avLst/>
+          </a:prstGeom>
+          <a:noFill/>
+          <a:ln>
+            <a:noFill/>
+          </a:ln>
+        </p:spPr>
+        <p:txBody>
+          <a:bodyPr wrap="square" rtlCol="0">
+            <a:spAutoFit/>
+          </a:bodyPr>
+          <a:lstStyle/>
+          <a:p>
+            <a:r>
+              <a:rPr lang="fr-FR" sz="3200" dirty="0" err="1">
+                <a:latin typeface="Eras Light ITC" panose="020B0402030504020804" pitchFamily="34" charset="0"/>
+                <a:ea typeface="Microsoft JhengHei Light" panose="020B0304030504040204" pitchFamily="34" charset="-120"/>
+              </a:rPr>
+              <a:t>cProfile</a:t>
+            </a:r>
+            <a:r>
+              <a:rPr lang="fr-FR" sz="3200" dirty="0">
+                <a:latin typeface="Eras Light ITC" panose="020B0402030504020804" pitchFamily="34" charset="0"/>
+                <a:ea typeface="Microsoft JhengHei Light" panose="020B0304030504040204" pitchFamily="34" charset="-120"/>
+              </a:rPr>
+              <a:t> et o</a:t>
+            </a:r>
+            <a:r>
+              <a:rPr lang="fr-FR" sz="3200" noProof="0" dirty="0" err="1">
+                <a:latin typeface="Eras Light ITC" panose="020B0402030504020804" pitchFamily="34" charset="0"/>
+                <a:ea typeface="Microsoft JhengHei Light" panose="020B0304030504040204" pitchFamily="34" charset="-120"/>
+              </a:rPr>
+              <a:t>nnx</a:t>
+            </a:r>
+            <a:r>
+              <a:rPr lang="fr-FR" sz="3200" noProof="0" dirty="0">
+                <a:latin typeface="Eras Light ITC" panose="020B0402030504020804" pitchFamily="34" charset="0"/>
+                <a:ea typeface="Microsoft JhengHei Light" panose="020B0304030504040204" pitchFamily="34" charset="-120"/>
+              </a:rPr>
+              <a:t> runtime</a:t>
+            </a:r>
+            <a:endParaRPr lang="fr-FR" sz="3200" noProof="0" dirty="0">
+              <a:latin typeface="Eras Light ITC" panose="020B0402030504020804" pitchFamily="34" charset="0"/>
+              <a:ea typeface="Microsoft JhengHei UI Light" panose="020B0304030504040204" pitchFamily="34" charset="-120"/>
+            </a:endParaRPr>
+          </a:p>
+        </p:txBody>
+      </p:sp>
+      <p:sp>
+        <p:nvSpPr>
+          <p:cNvPr id="17" name="ZoneTexte 16">
+            <a:extLst>
+              <a:ext uri="{FF2B5EF4-FFF2-40B4-BE49-F238E27FC236}">
+                <a16:creationId xmlns:a16="http://schemas.microsoft.com/office/drawing/2014/main" id="{D451A7FD-3D56-75D0-BCA2-7CF2DAE1AC43}"/>
+              </a:ext>
+            </a:extLst>
+          </p:cNvPr>
+          <p:cNvSpPr txBox="1"/>
+          <p:nvPr/>
+        </p:nvSpPr>
+        <p:spPr>
+          <a:xfrm>
+            <a:off x="251709" y="3327586"/>
+            <a:ext cx="5301598" cy="1077218"/>
+          </a:xfrm>
+          <a:prstGeom prst="rect">
+            <a:avLst/>
+          </a:prstGeom>
+          <a:noFill/>
+          <a:ln>
+            <a:noFill/>
+          </a:ln>
+        </p:spPr>
+        <p:txBody>
+          <a:bodyPr wrap="square" rtlCol="0">
+            <a:spAutoFit/>
+          </a:bodyPr>
+          <a:lstStyle/>
+          <a:p>
+            <a:r>
+              <a:rPr lang="fr-FR" sz="3200" noProof="0" dirty="0">
+                <a:latin typeface="Eras Light ITC" panose="020B0402030504020804" pitchFamily="34" charset="0"/>
+                <a:ea typeface="Microsoft JhengHei Light" panose="020B0304030504040204" pitchFamily="34" charset="-120"/>
+              </a:rPr>
+              <a:t>Dur</a:t>
+            </a:r>
+            <a:r>
+              <a:rPr lang="fr-FR" sz="3200" dirty="0" err="1">
+                <a:latin typeface="Eras Light ITC" panose="020B0402030504020804" pitchFamily="34" charset="0"/>
+                <a:ea typeface="Microsoft JhengHei Light" panose="020B0304030504040204" pitchFamily="34" charset="-120"/>
+              </a:rPr>
+              <a:t>ée</a:t>
+            </a:r>
+            <a:r>
+              <a:rPr lang="fr-FR" sz="3200" dirty="0">
+                <a:latin typeface="Eras Light ITC" panose="020B0402030504020804" pitchFamily="34" charset="0"/>
+                <a:ea typeface="Microsoft JhengHei Light" panose="020B0304030504040204" pitchFamily="34" charset="-120"/>
+              </a:rPr>
+              <a:t> moyenne du pipeline : 18ms (Inférence = 66%)</a:t>
+            </a:r>
+            <a:endParaRPr lang="fr-FR" sz="3200" noProof="0" dirty="0">
+              <a:latin typeface="Eras Light ITC" panose="020B0402030504020804" pitchFamily="34" charset="0"/>
+              <a:ea typeface="Microsoft JhengHei UI Light" panose="020B0304030504040204" pitchFamily="34" charset="-120"/>
+            </a:endParaRPr>
+          </a:p>
+        </p:txBody>
+      </p:sp>
+      <p:sp>
+        <p:nvSpPr>
+          <p:cNvPr id="2" name="Rectangle 1">
+            <a:extLst>
+              <a:ext uri="{FF2B5EF4-FFF2-40B4-BE49-F238E27FC236}">
+                <a16:creationId xmlns:a16="http://schemas.microsoft.com/office/drawing/2014/main" id="{A78C720F-D9C4-D524-5B7E-2B3C77C2F393}"/>
+              </a:ext>
+            </a:extLst>
+          </p:cNvPr>
+          <p:cNvSpPr/>
+          <p:nvPr/>
+        </p:nvSpPr>
+        <p:spPr>
+          <a:xfrm>
+            <a:off x="251709" y="4805680"/>
+            <a:ext cx="4911306" cy="1077218"/>
+          </a:xfrm>
+          <a:prstGeom prst="rect">
+            <a:avLst/>
+          </a:prstGeom>
+          <a:ln>
+            <a:solidFill>
+              <a:schemeClr val="bg2"/>
+            </a:solidFill>
+          </a:ln>
+        </p:spPr>
+        <p:style>
+          <a:lnRef idx="2">
+            <a:schemeClr val="accent1">
+              <a:shade val="15000"/>
+            </a:schemeClr>
+          </a:lnRef>
+          <a:fillRef idx="1">
+            <a:schemeClr val="accent1"/>
+          </a:fillRef>
+          <a:effectRef idx="0">
+            <a:schemeClr val="accent1"/>
+          </a:effectRef>
+          <a:fontRef idx="minor">
+            <a:schemeClr val="lt1"/>
+          </a:fontRef>
+        </p:style>
+        <p:txBody>
+          <a:bodyPr rtlCol="0" anchor="ctr"/>
+          <a:lstStyle/>
+          <a:p>
+            <a:pPr algn="ctr"/>
+            <a:endParaRPr lang="fr-FR"/>
+          </a:p>
+        </p:txBody>
+      </p:sp>
+      <p:cxnSp>
+        <p:nvCxnSpPr>
+          <p:cNvPr id="4" name="Straight Arrow Connector 3">
+            <a:extLst>
+              <a:ext uri="{FF2B5EF4-FFF2-40B4-BE49-F238E27FC236}">
+                <a16:creationId xmlns:a16="http://schemas.microsoft.com/office/drawing/2014/main" id="{90FD56F8-7CB9-C210-E32E-734AD7BC82FF}"/>
+              </a:ext>
+            </a:extLst>
+          </p:cNvPr>
+          <p:cNvCxnSpPr>
+            <a:cxnSpLocks/>
+          </p:cNvCxnSpPr>
+          <p:nvPr/>
+        </p:nvCxnSpPr>
+        <p:spPr>
+          <a:xfrm>
+            <a:off x="462880" y="5100320"/>
+            <a:ext cx="624240" cy="0"/>
+          </a:xfrm>
+          <a:prstGeom prst="straightConnector1">
+            <a:avLst/>
+          </a:prstGeom>
+          <a:ln w="38100">
+            <a:solidFill>
+              <a:schemeClr val="tx1"/>
+            </a:solidFill>
+            <a:headEnd type="none" w="med" len="med"/>
+            <a:tailEnd type="arrow" w="med" len="med"/>
+          </a:ln>
+        </p:spPr>
+        <p:style>
+          <a:lnRef idx="1">
+            <a:schemeClr val="accent1"/>
+          </a:lnRef>
+          <a:fillRef idx="0">
+            <a:schemeClr val="accent1"/>
+          </a:fillRef>
+          <a:effectRef idx="0">
+            <a:schemeClr val="accent1"/>
+          </a:effectRef>
+          <a:fontRef idx="minor">
+            <a:schemeClr val="tx1"/>
+          </a:fontRef>
+        </p:style>
+      </p:cxnSp>
+      <p:sp>
+        <p:nvSpPr>
+          <p:cNvPr id="6" name="ZoneTexte 12">
+            <a:extLst>
+              <a:ext uri="{FF2B5EF4-FFF2-40B4-BE49-F238E27FC236}">
+                <a16:creationId xmlns:a16="http://schemas.microsoft.com/office/drawing/2014/main" id="{976ADC03-2BC2-DCE7-30A4-68335B28A399}"/>
+              </a:ext>
+            </a:extLst>
+          </p:cNvPr>
+          <p:cNvSpPr txBox="1"/>
+          <p:nvPr/>
+        </p:nvSpPr>
+        <p:spPr>
+          <a:xfrm>
+            <a:off x="1263340" y="4896991"/>
+            <a:ext cx="3899675" cy="830997"/>
+          </a:xfrm>
+          <a:prstGeom prst="rect">
+            <a:avLst/>
+          </a:prstGeom>
+          <a:noFill/>
+          <a:ln>
+            <a:noFill/>
+          </a:ln>
+        </p:spPr>
+        <p:txBody>
+          <a:bodyPr wrap="square" rtlCol="0">
+            <a:spAutoFit/>
+          </a:bodyPr>
+          <a:lstStyle/>
+          <a:p>
+            <a:r>
+              <a:rPr lang="fr-FR" sz="2400" b="1" dirty="0">
+                <a:latin typeface="Eras Light ITC" panose="020B0402030504020804" pitchFamily="34" charset="0"/>
+                <a:ea typeface="Microsoft JhengHei Light" panose="020B0304030504040204" pitchFamily="34" charset="-120"/>
+              </a:rPr>
+              <a:t>Temps de traitement moyen divisé par 2.</a:t>
+            </a:r>
+            <a:endParaRPr lang="fr-FR" sz="2400" b="1" noProof="0" dirty="0">
+              <a:latin typeface="Eras Light ITC" panose="020B0402030504020804" pitchFamily="34" charset="0"/>
+              <a:ea typeface="Microsoft JhengHei UI Light" panose="020B0304030504040204" pitchFamily="34" charset="-120"/>
+            </a:endParaRPr>
+          </a:p>
+        </p:txBody>
+      </p:sp>
+    </p:spTree>
+    <p:extLst>
+      <p:ext uri="{BB962C8B-B14F-4D97-AF65-F5344CB8AC3E}">
+        <p14:creationId xmlns:p14="http://schemas.microsoft.com/office/powerpoint/2010/main" val="3176112927"/>
+      </p:ext>
+    </p:extLst>
+  </p:cSld>
+  <p:clrMapOvr>
+    <a:masterClrMapping/>
+  </p:clrMapOvr>
+</p:sld>
+</file>
+
+<file path=ppt/slides/slide11.xml><?xml version="1.0" encoding="utf-8"?>
+<p:sld xmlns:a="http://schemas.openxmlformats.org/drawingml/2006/main" xmlns:r="http://schemas.openxmlformats.org/officeDocument/2006/relationships" xmlns:p="http://schemas.openxmlformats.org/presentationml/2006/main">
+  <p:cSld>
+    <p:spTree>
+      <p:nvGrpSpPr>
+        <p:cNvPr id="1" name="">
+          <a:extLst>
+            <a:ext uri="{FF2B5EF4-FFF2-40B4-BE49-F238E27FC236}">
               <a16:creationId xmlns:a16="http://schemas.microsoft.com/office/drawing/2014/main" id="{8504BBA8-251F-CE49-558E-F48B846E23C5}"/>
             </a:ext>
           </a:extLst>
@@ -10513,7 +10715,7 @@
         <p:spPr>
           <a:xfrm>
             <a:off x="381600" y="2268350"/>
-            <a:ext cx="10546510" cy="954107"/>
+            <a:ext cx="10546510" cy="1384995"/>
           </a:xfrm>
           <a:prstGeom prst="rect">
             <a:avLst/>
@@ -10545,14 +10747,35 @@
                 <a:latin typeface="Eras Light ITC" panose="020B0402030504020804" pitchFamily="34" charset="0"/>
                 <a:ea typeface="Microsoft JhengHei UI" panose="020B0604030504040204" pitchFamily="34" charset="-120"/>
               </a:rPr>
-              <a:t>FastAPI</a:t>
+              <a:t>gradio</a:t>
             </a:r>
             <a:r>
               <a:rPr lang="fr-FR" sz="2800" noProof="0" dirty="0">
                 <a:latin typeface="Eras Light ITC" panose="020B0402030504020804" pitchFamily="34" charset="0"/>
                 <a:ea typeface="Microsoft JhengHei UI" panose="020B0604030504040204" pitchFamily="34" charset="-120"/>
               </a:rPr>
-              <a:t> fonctionnelle pour l’exposition d’un modèle de classification.</a:t>
+              <a:t> fonctionnelle permettant d’obtenir une prédiction du modèle de </a:t>
+            </a:r>
+            <a:r>
+              <a:rPr lang="fr-FR" sz="2800" noProof="0" dirty="0" err="1">
+                <a:latin typeface="Eras Light ITC" panose="020B0402030504020804" pitchFamily="34" charset="0"/>
+                <a:ea typeface="Microsoft JhengHei UI" panose="020B0604030504040204" pitchFamily="34" charset="-120"/>
+              </a:rPr>
+              <a:t>scoring</a:t>
+            </a:r>
+            <a:r>
+              <a:rPr lang="fr-FR" sz="2800" noProof="0" dirty="0">
+                <a:latin typeface="Eras Light ITC" panose="020B0402030504020804" pitchFamily="34" charset="0"/>
+                <a:ea typeface="Microsoft JhengHei UI" panose="020B0604030504040204" pitchFamily="34" charset="-120"/>
+              </a:rPr>
+              <a:t> à partir de nouvelles valeurs des variables les plus explicatives du </a:t>
+            </a:r>
+            <a:r>
+              <a:rPr lang="fr-FR" sz="2800" noProof="0" dirty="0" err="1">
+                <a:latin typeface="Eras Light ITC" panose="020B0402030504020804" pitchFamily="34" charset="0"/>
+                <a:ea typeface="Microsoft JhengHei UI" panose="020B0604030504040204" pitchFamily="34" charset="-120"/>
+              </a:rPr>
+              <a:t>scoring</a:t>
             </a:r>
             <a:endParaRPr lang="fr-FR" sz="2800" i="1" noProof="0" dirty="0">
               <a:latin typeface="Eras Light ITC" panose="020B0402030504020804" pitchFamily="34" charset="0"/>
@@ -10575,7 +10798,7 @@
         </p:nvSpPr>
         <p:spPr>
           <a:xfrm>
-            <a:off x="381600" y="3379545"/>
+            <a:off x="371440" y="3765625"/>
             <a:ext cx="10546510" cy="1384995"/>
           </a:xfrm>
           <a:prstGeom prst="rect">
@@ -10642,62 +10865,6 @@
               <a:latin typeface="Eras Light ITC" panose="020B0402030504020804" pitchFamily="34" charset="0"/>
               <a:ea typeface="Microsoft JhengHei UI Light" panose="020B0304030504040204" pitchFamily="34" charset="-120"/>
             </a:endParaRPr>
-          </a:p>
-        </p:txBody>
-      </p:sp>
-      <p:sp>
-        <p:nvSpPr>
-          <p:cNvPr id="10" name="ZoneTexte 9">
-            <a:extLst>
-              <a:ext uri="{FF2B5EF4-FFF2-40B4-BE49-F238E27FC236}">
-                <a16:creationId xmlns:a16="http://schemas.microsoft.com/office/drawing/2014/main" id="{DB9C21AA-C67A-2457-5C4B-9A5E8A659D19}"/>
-              </a:ext>
-            </a:extLst>
-          </p:cNvPr>
-          <p:cNvSpPr txBox="1"/>
-          <p:nvPr/>
-        </p:nvSpPr>
-        <p:spPr>
-          <a:xfrm>
-            <a:off x="381600" y="4921628"/>
-            <a:ext cx="10668000" cy="954107"/>
-          </a:xfrm>
-          <a:prstGeom prst="rect">
-            <a:avLst/>
-          </a:prstGeom>
-          <a:noFill/>
-        </p:spPr>
-        <p:txBody>
-          <a:bodyPr wrap="square">
-            <a:spAutoFit/>
-          </a:bodyPr>
-          <a:lstStyle/>
-          <a:p>
-            <a:pPr marL="457200" indent="-457200">
-              <a:buFont typeface="Arial" panose="020B0604020202020204" pitchFamily="34" charset="0"/>
-              <a:buChar char="•"/>
-            </a:pPr>
-            <a:r>
-              <a:rPr lang="fr-FR" sz="2800" noProof="0" dirty="0">
-                <a:latin typeface="Eras Light ITC" panose="020B0402030504020804" pitchFamily="34" charset="0"/>
-                <a:ea typeface="Microsoft JhengHei UI" panose="020B0604030504040204" pitchFamily="34" charset="-120"/>
-              </a:rPr>
-              <a:t>Mise en place d’une base de données PostgreSQL contenant le </a:t>
-            </a:r>
-            <a:r>
-              <a:rPr lang="fr-FR" sz="2800" noProof="0" dirty="0" err="1">
-                <a:latin typeface="Eras Light ITC" panose="020B0402030504020804" pitchFamily="34" charset="0"/>
-                <a:ea typeface="Microsoft JhengHei UI" panose="020B0604030504040204" pitchFamily="34" charset="-120"/>
-              </a:rPr>
-              <a:t>dataset</a:t>
-            </a:r>
-            <a:r>
-              <a:rPr lang="fr-FR" sz="2800" noProof="0" dirty="0">
-                <a:latin typeface="Eras Light ITC" panose="020B0402030504020804" pitchFamily="34" charset="0"/>
-                <a:ea typeface="Microsoft JhengHei UI" panose="020B0604030504040204" pitchFamily="34" charset="-120"/>
-              </a:rPr>
-              <a:t> et les logs d’activité de l’API.</a:t>
-            </a:r>
           </a:p>
         </p:txBody>
       </p:sp>
@@ -10738,17 +10905,17 @@
                 <a:latin typeface="Eras Light ITC" panose="020B0402030504020804" pitchFamily="34" charset="0"/>
                 <a:ea typeface="Microsoft JhengHei UI" panose="020B0604030504040204" pitchFamily="34" charset="-120"/>
               </a:rPr>
-              <a:t>Documentation complète de la procédure dans un README.</a:t>
-            </a:r>
-          </a:p>
-        </p:txBody>
-      </p:sp>
-      <p:sp>
-        <p:nvSpPr>
-          <p:cNvPr id="4" name="ZoneTexte 3">
+              <a:t>Documentation complète du projet.</a:t>
+            </a:r>
+          </a:p>
+        </p:txBody>
+      </p:sp>
+      <p:sp>
+        <p:nvSpPr>
+          <p:cNvPr id="6" name="ZoneTexte 7">
             <a:extLst>
               <a:ext uri="{FF2B5EF4-FFF2-40B4-BE49-F238E27FC236}">
-                <a16:creationId xmlns:a16="http://schemas.microsoft.com/office/drawing/2014/main" id="{519EEC43-7E32-DD0D-1577-F4008E00011B}"/>
+                <a16:creationId xmlns:a16="http://schemas.microsoft.com/office/drawing/2014/main" id="{BBCFF9EA-1D53-528D-15D9-153B334FB7B8}"/>
               </a:ext>
             </a:extLst>
           </p:cNvPr>
@@ -10756,35 +10923,45 @@
           <p:nvPr/>
         </p:nvSpPr>
         <p:spPr>
-          <a:xfrm rot="18595855">
-            <a:off x="2422464" y="2187231"/>
-            <a:ext cx="6464783" cy="2646878"/>
+          <a:xfrm>
+            <a:off x="361280" y="5295519"/>
+            <a:ext cx="10546510" cy="523220"/>
           </a:xfrm>
           <a:prstGeom prst="rect">
             <a:avLst/>
           </a:prstGeom>
-          <a:solidFill>
-            <a:schemeClr val="bg1"/>
-          </a:solidFill>
-        </p:spPr>
-        <p:txBody>
-          <a:bodyPr wrap="none" rtlCol="0">
+          <a:noFill/>
+          <a:ln>
+            <a:noFill/>
+          </a:ln>
+        </p:spPr>
+        <p:txBody>
+          <a:bodyPr wrap="square" rtlCol="0">
             <a:spAutoFit/>
           </a:bodyPr>
           <a:lstStyle/>
           <a:p>
-            <a:r>
-              <a:rPr lang="fr-FR" sz="16600" dirty="0">
-                <a:solidFill>
-                  <a:srgbClr val="FF0000"/>
-                </a:solidFill>
+            <a:pPr marL="457200" indent="-457200">
+              <a:buFont typeface="Arial" panose="020B0604020202020204" pitchFamily="34" charset="0"/>
+              <a:buChar char="•"/>
+            </a:pPr>
+            <a:r>
+              <a:rPr lang="fr-FR" sz="2800" noProof="0" dirty="0">
+                <a:latin typeface="Eras Light ITC" panose="020B0402030504020804" pitchFamily="34" charset="0"/>
+                <a:ea typeface="Microsoft JhengHei Light" panose="020B0304030504040204" pitchFamily="34" charset="-120"/>
               </a:rPr>
-              <a:t>A faire</a:t>
-            </a:r>
-            <a:endParaRPr lang="en-US" sz="16600" dirty="0">
-              <a:solidFill>
-                <a:srgbClr val="FF0000"/>
-              </a:solidFill>
+              <a:t>Optimisation du pipeline	</a:t>
+            </a:r>
+            <a:r>
+              <a:rPr lang="fr-FR" sz="2800" i="1" noProof="0" dirty="0">
+                <a:latin typeface="Eras Light ITC" panose="020B0402030504020804" pitchFamily="34" charset="0"/>
+                <a:ea typeface="Microsoft JhengHei Light" panose="020B0304030504040204" pitchFamily="34" charset="-120"/>
+              </a:rPr>
+              <a:t>	</a:t>
+            </a:r>
+            <a:endParaRPr lang="fr-FR" sz="2800" i="1" noProof="0" dirty="0">
+              <a:latin typeface="Eras Light ITC" panose="020B0402030504020804" pitchFamily="34" charset="0"/>
+              <a:ea typeface="Microsoft JhengHei UI Light" panose="020B0304030504040204" pitchFamily="34" charset="-120"/>
             </a:endParaRPr>
           </a:p>
         </p:txBody>
@@ -13103,14 +13280,15 @@
               </a:ext>
             </a:extLst>
           </a:blip>
+          <a:srcRect l="30176" r="27750" b="68498"/>
           <a:stretch>
             <a:fillRect/>
           </a:stretch>
         </p:blipFill>
         <p:spPr>
           <a:xfrm>
-            <a:off x="5872480" y="1534160"/>
-            <a:ext cx="6151802" cy="5041060"/>
+            <a:off x="5729527" y="1499753"/>
+            <a:ext cx="6210764" cy="5236327"/>
           </a:xfrm>
           <a:prstGeom prst="rect">
             <a:avLst/>
@@ -13197,7 +13375,7 @@
         <p:cNvPr id="1" name="">
           <a:extLst>
             <a:ext uri="{FF2B5EF4-FFF2-40B4-BE49-F238E27FC236}">
-              <a16:creationId xmlns:a16="http://schemas.microsoft.com/office/drawing/2014/main" id="{AF761774-17B2-316B-B5E3-C8ECC654D36E}"/>
+              <a16:creationId xmlns:a16="http://schemas.microsoft.com/office/drawing/2014/main" id="{1FC49C27-CEE7-B1FC-08CB-E986C3C15918}"/>
             </a:ext>
           </a:extLst>
         </p:cNvPr>
@@ -13217,7 +13395,7 @@
           <p:cNvPr id="5" name="ZoneTexte 4">
             <a:extLst>
               <a:ext uri="{FF2B5EF4-FFF2-40B4-BE49-F238E27FC236}">
-                <a16:creationId xmlns:a16="http://schemas.microsoft.com/office/drawing/2014/main" id="{3894094E-56AD-D7E0-BF48-63B4518BF1FC}"/>
+                <a16:creationId xmlns:a16="http://schemas.microsoft.com/office/drawing/2014/main" id="{22F87969-F3B0-FD80-3705-67C81F733544}"/>
               </a:ext>
             </a:extLst>
           </p:cNvPr>
@@ -13255,12 +13433,121 @@
           </a:p>
         </p:txBody>
       </p:sp>
+      <p:sp>
+        <p:nvSpPr>
+          <p:cNvPr id="4" name="ZoneTexte 3">
+            <a:extLst>
+              <a:ext uri="{FF2B5EF4-FFF2-40B4-BE49-F238E27FC236}">
+                <a16:creationId xmlns:a16="http://schemas.microsoft.com/office/drawing/2014/main" id="{D71AAED4-AF28-9D47-A41A-0ADECF4D0551}"/>
+              </a:ext>
+            </a:extLst>
+          </p:cNvPr>
+          <p:cNvSpPr txBox="1"/>
+          <p:nvPr/>
+        </p:nvSpPr>
+        <p:spPr>
+          <a:xfrm>
+            <a:off x="167718" y="2076886"/>
+            <a:ext cx="5796202" cy="584775"/>
+          </a:xfrm>
+          <a:prstGeom prst="rect">
+            <a:avLst/>
+          </a:prstGeom>
+          <a:noFill/>
+          <a:ln>
+            <a:noFill/>
+          </a:ln>
+        </p:spPr>
+        <p:txBody>
+          <a:bodyPr wrap="square" rtlCol="0">
+            <a:spAutoFit/>
+          </a:bodyPr>
+          <a:lstStyle/>
+          <a:p>
+            <a:r>
+              <a:rPr lang="fr-FR" sz="3200" b="1" noProof="0" dirty="0">
+                <a:ea typeface="Microsoft JhengHei UI" panose="020B0604030504040204" pitchFamily="34" charset="-120"/>
+              </a:rPr>
+              <a:t>Optimisation du modèle :</a:t>
+            </a:r>
+            <a:endParaRPr lang="fr-FR" sz="3200" i="1" noProof="0" dirty="0">
+              <a:ea typeface="Microsoft JhengHei UI Light" panose="020B0304030504040204" pitchFamily="34" charset="-120"/>
+            </a:endParaRPr>
+          </a:p>
+        </p:txBody>
+      </p:sp>
+      <p:sp>
+        <p:nvSpPr>
+          <p:cNvPr id="7" name="ZoneTexte 6">
+            <a:extLst>
+              <a:ext uri="{FF2B5EF4-FFF2-40B4-BE49-F238E27FC236}">
+                <a16:creationId xmlns:a16="http://schemas.microsoft.com/office/drawing/2014/main" id="{390D90A3-2E34-7CF3-7374-35C62EB697DC}"/>
+              </a:ext>
+            </a:extLst>
+          </p:cNvPr>
+          <p:cNvSpPr txBox="1"/>
+          <p:nvPr/>
+        </p:nvSpPr>
+        <p:spPr>
+          <a:xfrm>
+            <a:off x="251709" y="2490577"/>
+            <a:ext cx="4911306" cy="584775"/>
+          </a:xfrm>
+          <a:prstGeom prst="rect">
+            <a:avLst/>
+          </a:prstGeom>
+          <a:noFill/>
+          <a:ln>
+            <a:noFill/>
+          </a:ln>
+        </p:spPr>
+        <p:txBody>
+          <a:bodyPr wrap="square" rtlCol="0">
+            <a:spAutoFit/>
+          </a:bodyPr>
+          <a:lstStyle/>
+          <a:p>
+            <a:r>
+              <a:rPr lang="fr-FR" sz="3200" dirty="0" err="1">
+                <a:latin typeface="Eras Light ITC" panose="020B0402030504020804" pitchFamily="34" charset="0"/>
+                <a:ea typeface="Microsoft JhengHei Light" panose="020B0304030504040204" pitchFamily="34" charset="-120"/>
+              </a:rPr>
+              <a:t>cProfile</a:t>
+            </a:r>
+            <a:r>
+              <a:rPr lang="fr-FR" sz="3200" dirty="0">
+                <a:latin typeface="Eras Light ITC" panose="020B0402030504020804" pitchFamily="34" charset="0"/>
+                <a:ea typeface="Microsoft JhengHei Light" panose="020B0304030504040204" pitchFamily="34" charset="-120"/>
+              </a:rPr>
+              <a:t> et o</a:t>
+            </a:r>
+            <a:r>
+              <a:rPr lang="fr-FR" sz="3200" noProof="0" dirty="0" err="1">
+                <a:latin typeface="Eras Light ITC" panose="020B0402030504020804" pitchFamily="34" charset="0"/>
+                <a:ea typeface="Microsoft JhengHei Light" panose="020B0304030504040204" pitchFamily="34" charset="-120"/>
+              </a:rPr>
+              <a:t>nnx</a:t>
+            </a:r>
+            <a:r>
+              <a:rPr lang="fr-FR" sz="3200" noProof="0" dirty="0">
+                <a:latin typeface="Eras Light ITC" panose="020B0402030504020804" pitchFamily="34" charset="0"/>
+                <a:ea typeface="Microsoft JhengHei Light" panose="020B0304030504040204" pitchFamily="34" charset="-120"/>
+              </a:rPr>
+              <a:t> runtime</a:t>
+            </a:r>
+            <a:endParaRPr lang="fr-FR" sz="3200" noProof="0" dirty="0">
+              <a:latin typeface="Eras Light ITC" panose="020B0402030504020804" pitchFamily="34" charset="0"/>
+              <a:ea typeface="Microsoft JhengHei UI Light" panose="020B0304030504040204" pitchFamily="34" charset="-120"/>
+            </a:endParaRPr>
+          </a:p>
+        </p:txBody>
+      </p:sp>
       <p:pic>
         <p:nvPicPr>
-          <p:cNvPr id="3" name="Image 2">
+          <p:cNvPr id="11" name="Image 10">
             <a:extLst>
               <a:ext uri="{FF2B5EF4-FFF2-40B4-BE49-F238E27FC236}">
-                <a16:creationId xmlns:a16="http://schemas.microsoft.com/office/drawing/2014/main" id="{4779BAFB-8C55-6147-EDE8-D3C1F8FF0C89}"/>
+                <a16:creationId xmlns:a16="http://schemas.microsoft.com/office/drawing/2014/main" id="{7350D8FA-E376-4F41-2F73-FF8D81A23F3E}"/>
               </a:ext>
             </a:extLst>
           </p:cNvPr>
@@ -13277,14 +13564,15 @@
               </a:ext>
             </a:extLst>
           </a:blip>
+          <a:srcRect l="30176" r="27750" b="68498"/>
           <a:stretch>
             <a:fillRect/>
           </a:stretch>
         </p:blipFill>
         <p:spPr>
           <a:xfrm>
-            <a:off x="5471824" y="2184140"/>
-            <a:ext cx="6552458" cy="4376997"/>
+            <a:off x="5729527" y="1499753"/>
+            <a:ext cx="6210764" cy="5236327"/>
           </a:xfrm>
           <a:prstGeom prst="rect">
             <a:avLst/>
@@ -13293,10 +13581,10 @@
       </p:pic>
       <p:sp>
         <p:nvSpPr>
-          <p:cNvPr id="8" name="ZoneTexte 7">
+          <p:cNvPr id="13" name="ZoneTexte 12">
             <a:extLst>
               <a:ext uri="{FF2B5EF4-FFF2-40B4-BE49-F238E27FC236}">
-                <a16:creationId xmlns:a16="http://schemas.microsoft.com/office/drawing/2014/main" id="{B94ACE82-35E3-E7B1-A889-4608302337A5}"/>
+                <a16:creationId xmlns:a16="http://schemas.microsoft.com/office/drawing/2014/main" id="{8A837EFC-4D4B-87AC-80B1-02A4A8E96D5B}"/>
               </a:ext>
             </a:extLst>
           </p:cNvPr>
@@ -13305,8 +13593,8 @@
         </p:nvSpPr>
         <p:spPr>
           <a:xfrm>
-            <a:off x="167718" y="2076886"/>
-            <a:ext cx="5796202" cy="584775"/>
+            <a:off x="251709" y="3327586"/>
+            <a:ext cx="5301598" cy="1077218"/>
           </a:xfrm>
           <a:prstGeom prst="rect">
             <a:avLst/>
@@ -13323,12 +13611,28 @@
           <a:lstStyle/>
           <a:p>
             <a:r>
-              <a:rPr lang="fr-FR" sz="3200" b="1" noProof="0" dirty="0">
-                <a:ea typeface="Microsoft JhengHei UI" panose="020B0604030504040204" pitchFamily="34" charset="-120"/>
+              <a:rPr lang="fr-FR" sz="3200" noProof="0" dirty="0">
+                <a:latin typeface="Eras Light ITC" panose="020B0402030504020804" pitchFamily="34" charset="0"/>
+                <a:ea typeface="Microsoft JhengHei Light" panose="020B0304030504040204" pitchFamily="34" charset="-120"/>
               </a:rPr>
-              <a:t>Optimisation du modèle :</a:t>
-            </a:r>
-            <a:endParaRPr lang="fr-FR" sz="3200" i="1" noProof="0" dirty="0">
+              <a:t>Dur</a:t>
+            </a:r>
+            <a:r>
+              <a:rPr lang="fr-FR" sz="3200" dirty="0" err="1">
+                <a:latin typeface="Eras Light ITC" panose="020B0402030504020804" pitchFamily="34" charset="0"/>
+                <a:ea typeface="Microsoft JhengHei Light" panose="020B0304030504040204" pitchFamily="34" charset="-120"/>
+              </a:rPr>
+              <a:t>ée</a:t>
+            </a:r>
+            <a:r>
+              <a:rPr lang="fr-FR" sz="3200" dirty="0">
+                <a:latin typeface="Eras Light ITC" panose="020B0402030504020804" pitchFamily="34" charset="0"/>
+                <a:ea typeface="Microsoft JhengHei Light" panose="020B0304030504040204" pitchFamily="34" charset="-120"/>
+              </a:rPr>
+              <a:t> moyenne du pipeline : 31ms (Inférence = 71%)</a:t>
+            </a:r>
+            <a:endParaRPr lang="fr-FR" sz="3200" noProof="0" dirty="0">
+              <a:latin typeface="Eras Light ITC" panose="020B0402030504020804" pitchFamily="34" charset="0"/>
               <a:ea typeface="Microsoft JhengHei UI Light" panose="020B0304030504040204" pitchFamily="34" charset="-120"/>
             </a:endParaRPr>
           </a:p>
@@ -13336,10 +13640,106 @@
       </p:sp>
       <p:sp>
         <p:nvSpPr>
-          <p:cNvPr id="15" name="ZoneTexte 14">
+          <p:cNvPr id="6" name="Rectangle 5">
             <a:extLst>
               <a:ext uri="{FF2B5EF4-FFF2-40B4-BE49-F238E27FC236}">
-                <a16:creationId xmlns:a16="http://schemas.microsoft.com/office/drawing/2014/main" id="{31995DC8-B439-6522-91A7-8AD4E4F1C465}"/>
+                <a16:creationId xmlns:a16="http://schemas.microsoft.com/office/drawing/2014/main" id="{4E6C1FF8-9486-1EFD-0405-642B3194A064}"/>
+              </a:ext>
+            </a:extLst>
+          </p:cNvPr>
+          <p:cNvSpPr/>
+          <p:nvPr/>
+        </p:nvSpPr>
+        <p:spPr>
+          <a:xfrm>
+            <a:off x="251709" y="4805680"/>
+            <a:ext cx="4911306" cy="1077218"/>
+          </a:xfrm>
+          <a:prstGeom prst="rect">
+            <a:avLst/>
+          </a:prstGeom>
+          <a:ln>
+            <a:solidFill>
+              <a:schemeClr val="bg2"/>
+            </a:solidFill>
+          </a:ln>
+        </p:spPr>
+        <p:style>
+          <a:lnRef idx="2">
+            <a:schemeClr val="accent1">
+              <a:shade val="15000"/>
+            </a:schemeClr>
+          </a:lnRef>
+          <a:fillRef idx="1">
+            <a:schemeClr val="accent1"/>
+          </a:fillRef>
+          <a:effectRef idx="0">
+            <a:schemeClr val="accent1"/>
+          </a:effectRef>
+          <a:fontRef idx="minor">
+            <a:schemeClr val="lt1"/>
+          </a:fontRef>
+        </p:style>
+        <p:txBody>
+          <a:bodyPr rtlCol="0" anchor="ctr"/>
+          <a:lstStyle/>
+          <a:p>
+            <a:pPr algn="ctr"/>
+            <a:endParaRPr lang="fr-FR"/>
+          </a:p>
+        </p:txBody>
+      </p:sp>
+      <p:cxnSp>
+        <p:nvCxnSpPr>
+          <p:cNvPr id="3" name="Straight Arrow Connector 2">
+            <a:extLst>
+              <a:ext uri="{FF2B5EF4-FFF2-40B4-BE49-F238E27FC236}">
+                <a16:creationId xmlns:a16="http://schemas.microsoft.com/office/drawing/2014/main" id="{7969D181-9F5F-C34D-5421-0DC22635D4C9}"/>
+              </a:ext>
+            </a:extLst>
+          </p:cNvPr>
+          <p:cNvCxnSpPr>
+            <a:cxnSpLocks/>
+          </p:cNvCxnSpPr>
+          <p:nvPr/>
+        </p:nvCxnSpPr>
+        <p:spPr>
+          <a:xfrm>
+            <a:off x="462880" y="5100320"/>
+            <a:ext cx="624240" cy="0"/>
+          </a:xfrm>
+          <a:prstGeom prst="straightConnector1">
+            <a:avLst/>
+          </a:prstGeom>
+          <a:ln w="38100">
+            <a:solidFill>
+              <a:schemeClr val="tx1"/>
+            </a:solidFill>
+            <a:headEnd type="none" w="med" len="med"/>
+            <a:tailEnd type="arrow" w="med" len="med"/>
+          </a:ln>
+        </p:spPr>
+        <p:style>
+          <a:lnRef idx="1">
+            <a:schemeClr val="accent1"/>
+          </a:lnRef>
+          <a:fillRef idx="0">
+            <a:schemeClr val="accent1"/>
+          </a:fillRef>
+          <a:effectRef idx="0">
+            <a:schemeClr val="accent1"/>
+          </a:effectRef>
+          <a:fontRef idx="minor">
+            <a:schemeClr val="tx1"/>
+          </a:fontRef>
+        </p:style>
+      </p:cxnSp>
+      <p:sp>
+        <p:nvSpPr>
+          <p:cNvPr id="9" name="ZoneTexte 12">
+            <a:extLst>
+              <a:ext uri="{FF2B5EF4-FFF2-40B4-BE49-F238E27FC236}">
+                <a16:creationId xmlns:a16="http://schemas.microsoft.com/office/drawing/2014/main" id="{3B86516C-D9E0-081D-8DFB-B2ECB61904BE}"/>
               </a:ext>
             </a:extLst>
           </p:cNvPr>
@@ -13348,8 +13748,8 @@
         </p:nvSpPr>
         <p:spPr>
           <a:xfrm>
-            <a:off x="251709" y="2490577"/>
-            <a:ext cx="4911306" cy="584775"/>
+            <a:off x="1263340" y="4896991"/>
+            <a:ext cx="3899675" cy="830997"/>
           </a:xfrm>
           <a:prstGeom prst="rect">
             <a:avLst/>
@@ -13366,103 +13766,143 @@
           <a:lstStyle/>
           <a:p>
             <a:r>
-              <a:rPr lang="fr-FR" sz="3200" dirty="0" err="1">
+              <a:rPr lang="fr-FR" sz="2400" b="1" noProof="0" dirty="0">
                 <a:latin typeface="Eras Light ITC" panose="020B0402030504020804" pitchFamily="34" charset="0"/>
                 <a:ea typeface="Microsoft JhengHei Light" panose="020B0304030504040204" pitchFamily="34" charset="-120"/>
               </a:rPr>
-              <a:t>cProfile</a:t>
-            </a:r>
-            <a:r>
-              <a:rPr lang="fr-FR" sz="3200" dirty="0">
+              <a:t>Goulot d’étranglement :</a:t>
+            </a:r>
+          </a:p>
+          <a:p>
+            <a:r>
+              <a:rPr lang="fr-FR" sz="2400" b="1" dirty="0" err="1">
                 <a:latin typeface="Eras Light ITC" panose="020B0402030504020804" pitchFamily="34" charset="0"/>
                 <a:ea typeface="Microsoft JhengHei Light" panose="020B0304030504040204" pitchFamily="34" charset="-120"/>
               </a:rPr>
-              <a:t> et o</a:t>
-            </a:r>
-            <a:r>
-              <a:rPr lang="fr-FR" sz="3200" noProof="0" dirty="0" err="1">
+              <a:t>Sklearn</a:t>
+            </a:r>
+            <a:r>
+              <a:rPr lang="fr-FR" sz="2400" b="1" dirty="0">
                 <a:latin typeface="Eras Light ITC" panose="020B0402030504020804" pitchFamily="34" charset="0"/>
                 <a:ea typeface="Microsoft JhengHei Light" panose="020B0304030504040204" pitchFamily="34" charset="-120"/>
               </a:rPr>
-              <a:t>nnx</a:t>
-            </a:r>
-            <a:r>
-              <a:rPr lang="fr-FR" sz="3200" noProof="0" dirty="0">
+              <a:t>        fonction </a:t>
+            </a:r>
+            <a:r>
+              <a:rPr lang="fr-FR" sz="2400" b="1" dirty="0" err="1">
                 <a:latin typeface="Eras Light ITC" panose="020B0402030504020804" pitchFamily="34" charset="0"/>
                 <a:ea typeface="Microsoft JhengHei Light" panose="020B0304030504040204" pitchFamily="34" charset="-120"/>
               </a:rPr>
-              <a:t> runtime</a:t>
-            </a:r>
-            <a:endParaRPr lang="fr-FR" sz="3200" noProof="0" dirty="0">
+              <a:t>predict</a:t>
+            </a:r>
+            <a:endParaRPr lang="fr-FR" sz="2400" b="1" noProof="0" dirty="0">
               <a:latin typeface="Eras Light ITC" panose="020B0402030504020804" pitchFamily="34" charset="0"/>
               <a:ea typeface="Microsoft JhengHei UI Light" panose="020B0304030504040204" pitchFamily="34" charset="-120"/>
             </a:endParaRPr>
           </a:p>
         </p:txBody>
       </p:sp>
-      <p:sp>
-        <p:nvSpPr>
-          <p:cNvPr id="17" name="ZoneTexte 16">
+      <p:cxnSp>
+        <p:nvCxnSpPr>
+          <p:cNvPr id="10" name="Straight Arrow Connector 9">
             <a:extLst>
               <a:ext uri="{FF2B5EF4-FFF2-40B4-BE49-F238E27FC236}">
-                <a16:creationId xmlns:a16="http://schemas.microsoft.com/office/drawing/2014/main" id="{D451A7FD-3D56-75D0-BCA2-7CF2DAE1AC43}"/>
+                <a16:creationId xmlns:a16="http://schemas.microsoft.com/office/drawing/2014/main" id="{2FD128D9-A2B3-5171-F470-DA891210B821}"/>
               </a:ext>
             </a:extLst>
           </p:cNvPr>
-          <p:cNvSpPr txBox="1"/>
+          <p:cNvCxnSpPr>
+            <a:cxnSpLocks/>
+          </p:cNvCxnSpPr>
           <p:nvPr/>
-        </p:nvSpPr>
-        <p:spPr>
-          <a:xfrm>
-            <a:off x="251709" y="3327586"/>
-            <a:ext cx="5301598" cy="1077218"/>
-          </a:xfrm>
-          <a:prstGeom prst="rect">
+        </p:nvCxnSpPr>
+        <p:spPr>
+          <a:xfrm>
+            <a:off x="2398082" y="5506720"/>
+            <a:ext cx="360080" cy="0"/>
+          </a:xfrm>
+          <a:prstGeom prst="straightConnector1">
+            <a:avLst/>
+          </a:prstGeom>
+          <a:ln w="38100">
+            <a:solidFill>
+              <a:schemeClr val="tx1"/>
+            </a:solidFill>
+            <a:headEnd type="none" w="med" len="med"/>
+            <a:tailEnd type="arrow" w="med" len="med"/>
+          </a:ln>
+        </p:spPr>
+        <p:style>
+          <a:lnRef idx="1">
+            <a:schemeClr val="accent1"/>
+          </a:lnRef>
+          <a:fillRef idx="0">
+            <a:schemeClr val="accent1"/>
+          </a:fillRef>
+          <a:effectRef idx="0">
+            <a:schemeClr val="accent1"/>
+          </a:effectRef>
+          <a:fontRef idx="minor">
+            <a:schemeClr val="tx1"/>
+          </a:fontRef>
+        </p:style>
+      </p:cxnSp>
+      <p:sp>
+        <p:nvSpPr>
+          <p:cNvPr id="2" name="Oval 1">
+            <a:extLst>
+              <a:ext uri="{FF2B5EF4-FFF2-40B4-BE49-F238E27FC236}">
+                <a16:creationId xmlns:a16="http://schemas.microsoft.com/office/drawing/2014/main" id="{BD4B49C7-2D25-1428-2A46-63838E6F8242}"/>
+              </a:ext>
+            </a:extLst>
+          </p:cNvPr>
+          <p:cNvSpPr/>
+          <p:nvPr/>
+        </p:nvSpPr>
+        <p:spPr>
+          <a:xfrm>
+            <a:off x="5729527" y="2684227"/>
+            <a:ext cx="1310640" cy="1512113"/>
+          </a:xfrm>
+          <a:prstGeom prst="ellipse">
             <a:avLst/>
           </a:prstGeom>
           <a:noFill/>
-          <a:ln>
-            <a:noFill/>
+          <a:ln w="57150">
+            <a:solidFill>
+              <a:srgbClr val="FF0000"/>
+            </a:solidFill>
           </a:ln>
         </p:spPr>
-        <p:txBody>
-          <a:bodyPr wrap="square" rtlCol="0">
-            <a:spAutoFit/>
-          </a:bodyPr>
+        <p:style>
+          <a:lnRef idx="2">
+            <a:schemeClr val="accent1">
+              <a:shade val="15000"/>
+            </a:schemeClr>
+          </a:lnRef>
+          <a:fillRef idx="1">
+            <a:schemeClr val="accent1"/>
+          </a:fillRef>
+          <a:effectRef idx="0">
+            <a:schemeClr val="accent1"/>
+          </a:effectRef>
+          <a:fontRef idx="minor">
+            <a:schemeClr val="lt1"/>
+          </a:fontRef>
+        </p:style>
+        <p:txBody>
+          <a:bodyPr rtlCol="0" anchor="ctr"/>
           <a:lstStyle/>
           <a:p>
-            <a:r>
-              <a:rPr lang="fr-FR" sz="3200" noProof="0" dirty="0">
-                <a:latin typeface="Eras Light ITC" panose="020B0402030504020804" pitchFamily="34" charset="0"/>
-                <a:ea typeface="Microsoft JhengHei Light" panose="020B0304030504040204" pitchFamily="34" charset="-120"/>
-              </a:rPr>
-              <a:t>Dur</a:t>
-            </a:r>
-            <a:r>
-              <a:rPr lang="fr-FR" sz="3200" dirty="0" err="1">
-                <a:latin typeface="Eras Light ITC" panose="020B0402030504020804" pitchFamily="34" charset="0"/>
-                <a:ea typeface="Microsoft JhengHei Light" panose="020B0304030504040204" pitchFamily="34" charset="-120"/>
-              </a:rPr>
-              <a:t>ée</a:t>
-            </a:r>
-            <a:r>
-              <a:rPr lang="fr-FR" sz="3200" dirty="0">
-                <a:latin typeface="Eras Light ITC" panose="020B0402030504020804" pitchFamily="34" charset="0"/>
-                <a:ea typeface="Microsoft JhengHei Light" panose="020B0304030504040204" pitchFamily="34" charset="-120"/>
-              </a:rPr>
-              <a:t> moyenne du pipeline : 18ms (Inférence = 66%)</a:t>
-            </a:r>
-            <a:endParaRPr lang="fr-FR" sz="3200" noProof="0" dirty="0">
-              <a:latin typeface="Eras Light ITC" panose="020B0402030504020804" pitchFamily="34" charset="0"/>
-              <a:ea typeface="Microsoft JhengHei UI Light" panose="020B0304030504040204" pitchFamily="34" charset="-120"/>
-            </a:endParaRPr>
+            <a:pPr algn="ctr"/>
+            <a:endParaRPr lang="fr-FR"/>
           </a:p>
         </p:txBody>
       </p:sp>
     </p:spTree>
     <p:extLst>
       <p:ext uri="{BB962C8B-B14F-4D97-AF65-F5344CB8AC3E}">
-        <p14:creationId xmlns:p14="http://schemas.microsoft.com/office/powerpoint/2010/main" val="3176112927"/>
+        <p14:creationId xmlns:p14="http://schemas.microsoft.com/office/powerpoint/2010/main" val="2113280459"/>
       </p:ext>
     </p:extLst>
   </p:cSld>

</xml_diff>

<commit_message>
correct several elements and add data drift notebook
</commit_message>
<xml_diff>
--- a/reports/oc-projet-8.pptx
+++ b/reports/oc-projet-8.pptx
@@ -225,7 +225,7 @@
           <a:p>
             <a:fld id="{65DDB058-A044-4043-A3A3-7BACA5B3A04F}" type="datetimeFigureOut">
               <a:rPr lang="en-US" smtClean="0"/>
-              <a:t>8/17/2026</a:t>
+              <a:t>8/22/2026</a:t>
             </a:fld>
             <a:endParaRPr lang="en-US"/>
           </a:p>
@@ -402,7 +402,7 @@
           <a:p>
             <a:fld id="{AA1CF6E6-CAE2-4C00-8C24-5E0E8B2FFA08}" type="datetimeFigureOut">
               <a:rPr lang="en-US" smtClean="0"/>
-              <a:t>8/17/2026</a:t>
+              <a:t>8/22/2026</a:t>
             </a:fld>
             <a:endParaRPr lang="en-US"/>
           </a:p>
@@ -714,7 +714,90 @@
           <a:bodyPr/>
           <a:lstStyle/>
           <a:p>
-            <a:endParaRPr lang="en-US" dirty="0"/>
+            <a:r>
+              <a:rPr lang="en-US" dirty="0"/>
+              <a:t>Bonjour, je </a:t>
+            </a:r>
+            <a:r>
+              <a:rPr lang="en-US" dirty="0" err="1"/>
+              <a:t>vais</a:t>
+            </a:r>
+            <a:r>
+              <a:rPr lang="en-US" dirty="0"/>
+              <a:t> vous presenter </a:t>
+            </a:r>
+            <a:r>
+              <a:rPr lang="en-US" dirty="0" err="1"/>
+              <a:t>mon</a:t>
+            </a:r>
+            <a:r>
+              <a:rPr lang="en-US" dirty="0"/>
+              <a:t> travail pour le </a:t>
+            </a:r>
+            <a:r>
+              <a:rPr lang="en-US" dirty="0" err="1"/>
+              <a:t>projet</a:t>
+            </a:r>
+            <a:r>
+              <a:rPr lang="en-US" dirty="0"/>
+              <a:t> 8 du </a:t>
+            </a:r>
+            <a:r>
+              <a:rPr lang="en-US" dirty="0" err="1"/>
+              <a:t>parcours</a:t>
+            </a:r>
+            <a:r>
+              <a:rPr lang="en-US" dirty="0"/>
+              <a:t> </a:t>
+            </a:r>
+            <a:r>
+              <a:rPr lang="en-US" dirty="0" err="1"/>
+              <a:t>datascience</a:t>
+            </a:r>
+            <a:r>
+              <a:rPr lang="en-US" dirty="0"/>
+              <a:t>, </a:t>
+            </a:r>
+            <a:r>
+              <a:rPr lang="en-US" dirty="0" err="1"/>
+              <a:t>confirmez</a:t>
+            </a:r>
+            <a:r>
+              <a:rPr lang="en-US" dirty="0"/>
+              <a:t> </a:t>
+            </a:r>
+            <a:r>
+              <a:rPr lang="en-US" dirty="0" err="1"/>
+              <a:t>vos</a:t>
+            </a:r>
+            <a:r>
+              <a:rPr lang="en-US" dirty="0"/>
+              <a:t> </a:t>
+            </a:r>
+            <a:r>
+              <a:rPr lang="en-US" dirty="0" err="1"/>
+              <a:t>compétences</a:t>
+            </a:r>
+            <a:r>
+              <a:rPr lang="en-US" dirty="0"/>
+              <a:t> </a:t>
+            </a:r>
+            <a:r>
+              <a:rPr lang="en-US" dirty="0" err="1"/>
+              <a:t>en</a:t>
+            </a:r>
+            <a:r>
+              <a:rPr lang="en-US" dirty="0"/>
+              <a:t> </a:t>
+            </a:r>
+            <a:r>
+              <a:rPr lang="en-US" dirty="0" err="1"/>
+              <a:t>MLOps</a:t>
+            </a:r>
+            <a:r>
+              <a:rPr lang="en-US" dirty="0"/>
+              <a:t>.</a:t>
+            </a:r>
           </a:p>
         </p:txBody>
       </p:sp>
@@ -843,7 +926,7 @@
                 <a:ea typeface="+mn-ea"/>
                 <a:cs typeface="+mn-cs"/>
               </a:rPr>
-              <a:t>Déploiement sur </a:t>
+              <a:t>Ce qui ma permit de gagner 42% de temps moyen de requête. Donc en refaisant le profiling on voit que c’est toujours l’inférence qui prend le plus de temps mais l’objet </a:t>
             </a:r>
             <a:r>
               <a:rPr lang="fr-FR" sz="1200" kern="1200" dirty="0" err="1">
@@ -855,7 +938,31 @@
                 <a:ea typeface="+mn-ea"/>
                 <a:cs typeface="+mn-cs"/>
               </a:rPr>
-              <a:t>huggingface</a:t>
+              <a:t>onnx</a:t>
+            </a:r>
+            <a:r>
+              <a:rPr lang="fr-FR" sz="1200" kern="1200" dirty="0">
+                <a:solidFill>
+                  <a:schemeClr val="tx1"/>
+                </a:solidFill>
+                <a:effectLst/>
+                <a:latin typeface="+mn-lt"/>
+                <a:ea typeface="+mn-ea"/>
+                <a:cs typeface="+mn-cs"/>
+              </a:rPr>
+              <a:t> runtime est beaucoup plus rapide que le pipeline </a:t>
+            </a:r>
+            <a:r>
+              <a:rPr lang="fr-FR" sz="1200" kern="1200" dirty="0" err="1">
+                <a:solidFill>
+                  <a:schemeClr val="tx1"/>
+                </a:solidFill>
+                <a:effectLst/>
+                <a:latin typeface="+mn-lt"/>
+                <a:ea typeface="+mn-ea"/>
+                <a:cs typeface="+mn-cs"/>
+              </a:rPr>
+              <a:t>scikit</a:t>
             </a:r>
             <a:r>
               <a:rPr lang="fr-FR" sz="1200" kern="1200" dirty="0">
@@ -879,7 +986,7 @@
                 <a:ea typeface="+mn-ea"/>
                 <a:cs typeface="+mn-cs"/>
               </a:rPr>
-              <a:t>spaces</a:t>
+              <a:t>learn</a:t>
             </a:r>
             <a:r>
               <a:rPr lang="fr-FR" sz="1200" kern="1200" dirty="0">
@@ -891,19 +998,7 @@
                 <a:ea typeface="+mn-ea"/>
                 <a:cs typeface="+mn-cs"/>
               </a:rPr>
-              <a:t> =&gt; gestion des secrets et des variables =&gt; pas de BDD =&gt; route déploiement avec utilisation du csv, chemin vers le modèle et le tableau de données gérés comme variables d’environnement dans le repo </a:t>
-            </a:r>
-            <a:r>
-              <a:rPr lang="fr-FR" sz="1200" kern="1200" dirty="0" err="1">
-                <a:solidFill>
-                  <a:schemeClr val="tx1"/>
-                </a:solidFill>
-                <a:effectLst/>
-                <a:latin typeface="+mn-lt"/>
-                <a:ea typeface="+mn-ea"/>
-                <a:cs typeface="+mn-cs"/>
-              </a:rPr>
-              <a:t>space</a:t>
+              <a:t>. </a:t>
             </a:r>
             <a:endParaRPr lang="en-US" sz="1200" kern="1200" dirty="0">
               <a:solidFill>
@@ -1024,7 +1119,74 @@
           <a:bodyPr/>
           <a:lstStyle/>
           <a:p>
-            <a:endParaRPr lang="en-US" dirty="0"/>
+            <a:r>
+              <a:rPr lang="en-US" dirty="0"/>
+              <a:t>Ouverture sur la mise </a:t>
+            </a:r>
+            <a:r>
+              <a:rPr lang="en-US" dirty="0" err="1"/>
+              <a:t>en</a:t>
+            </a:r>
+            <a:r>
+              <a:rPr lang="en-US" dirty="0"/>
+              <a:t> </a:t>
+            </a:r>
+            <a:r>
+              <a:rPr lang="en-US" dirty="0" err="1"/>
+              <a:t>ligne</a:t>
+            </a:r>
+            <a:r>
+              <a:rPr lang="en-US" dirty="0"/>
+              <a:t> </a:t>
+            </a:r>
+            <a:r>
+              <a:rPr lang="en-US" dirty="0" err="1"/>
+              <a:t>d’une</a:t>
+            </a:r>
+            <a:r>
+              <a:rPr lang="en-US" dirty="0"/>
+              <a:t> base de données avec </a:t>
+            </a:r>
+            <a:r>
+              <a:rPr lang="en-US" dirty="0" err="1"/>
+              <a:t>connexion</a:t>
+            </a:r>
+            <a:r>
+              <a:rPr lang="en-US" dirty="0"/>
+              <a:t> à </a:t>
+            </a:r>
+            <a:r>
+              <a:rPr lang="en-US" dirty="0" err="1"/>
+              <a:t>l’api</a:t>
+            </a:r>
+            <a:r>
+              <a:rPr lang="en-US" dirty="0"/>
+              <a:t> </a:t>
+            </a:r>
+            <a:r>
+              <a:rPr lang="en-US" dirty="0" err="1"/>
+              <a:t>déployée</a:t>
+            </a:r>
+            <a:r>
+              <a:rPr lang="en-US" dirty="0"/>
+              <a:t> pour </a:t>
+            </a:r>
+            <a:r>
+              <a:rPr lang="en-US" dirty="0" err="1"/>
+              <a:t>pouvoir</a:t>
+            </a:r>
+            <a:r>
+              <a:rPr lang="en-US" dirty="0"/>
+              <a:t> la faire utilizer par des </a:t>
+            </a:r>
+            <a:r>
+              <a:rPr lang="en-US" dirty="0" err="1"/>
+              <a:t>personnes</a:t>
+            </a:r>
+            <a:r>
+              <a:rPr lang="en-US" dirty="0"/>
+              <a:t> externes.</a:t>
+            </a:r>
           </a:p>
         </p:txBody>
       </p:sp>
@@ -1114,7 +1276,186 @@
           <a:bodyPr/>
           <a:lstStyle/>
           <a:p>
-            <a:endParaRPr lang="en-US" dirty="0"/>
+            <a:r>
+              <a:rPr lang="en-US" dirty="0"/>
+              <a:t>Ma presentation se </a:t>
+            </a:r>
+            <a:r>
+              <a:rPr lang="en-US" dirty="0" err="1"/>
+              <a:t>divisera</a:t>
+            </a:r>
+            <a:r>
+              <a:rPr lang="en-US" dirty="0"/>
+              <a:t> </a:t>
+            </a:r>
+            <a:r>
+              <a:rPr lang="en-US" dirty="0" err="1"/>
+              <a:t>en</a:t>
+            </a:r>
+            <a:r>
+              <a:rPr lang="en-US" dirty="0"/>
+              <a:t> 4 points: je </a:t>
+            </a:r>
+            <a:r>
+              <a:rPr lang="en-US" dirty="0" err="1"/>
+              <a:t>ferai</a:t>
+            </a:r>
+            <a:r>
+              <a:rPr lang="en-US" dirty="0"/>
+              <a:t> </a:t>
+            </a:r>
+            <a:r>
+              <a:rPr lang="en-US" dirty="0" err="1"/>
+              <a:t>d’abord</a:t>
+            </a:r>
+            <a:r>
+              <a:rPr lang="en-US" dirty="0"/>
+              <a:t> un rappel du context métier, </a:t>
+            </a:r>
+            <a:r>
+              <a:rPr lang="en-US" dirty="0" err="1"/>
+              <a:t>suivi</a:t>
+            </a:r>
+            <a:r>
+              <a:rPr lang="en-US" dirty="0"/>
+              <a:t> de la </a:t>
+            </a:r>
+            <a:r>
+              <a:rPr lang="en-US" dirty="0" err="1"/>
+              <a:t>présentation</a:t>
+            </a:r>
+            <a:r>
+              <a:rPr lang="en-US" dirty="0"/>
+              <a:t> de la structure de </a:t>
+            </a:r>
+            <a:r>
+              <a:rPr lang="en-US" dirty="0" err="1"/>
+              <a:t>mon</a:t>
+            </a:r>
+            <a:r>
+              <a:rPr lang="en-US" dirty="0"/>
+              <a:t> </a:t>
+            </a:r>
+            <a:r>
+              <a:rPr lang="en-US" dirty="0" err="1"/>
+              <a:t>dépôt</a:t>
+            </a:r>
+            <a:r>
+              <a:rPr lang="en-US" dirty="0"/>
+              <a:t>. Je </a:t>
+            </a:r>
+            <a:r>
+              <a:rPr lang="en-US" dirty="0" err="1"/>
+              <a:t>ferai</a:t>
+            </a:r>
+            <a:r>
+              <a:rPr lang="en-US" dirty="0"/>
+              <a:t> ensuite </a:t>
+            </a:r>
+            <a:r>
+              <a:rPr lang="en-US" dirty="0" err="1"/>
+              <a:t>une</a:t>
+            </a:r>
+            <a:r>
+              <a:rPr lang="en-US" dirty="0"/>
+              <a:t> demonstration du </a:t>
+            </a:r>
+            <a:r>
+              <a:rPr lang="en-US" dirty="0" err="1"/>
+              <a:t>fonctionnement</a:t>
+            </a:r>
+            <a:r>
+              <a:rPr lang="en-US" dirty="0"/>
+              <a:t> de </a:t>
+            </a:r>
+            <a:r>
+              <a:rPr lang="en-US" dirty="0" err="1"/>
+              <a:t>mon</a:t>
+            </a:r>
+            <a:r>
+              <a:rPr lang="en-US" dirty="0"/>
+              <a:t> pipeline de ci/cd et de </a:t>
+            </a:r>
+            <a:r>
+              <a:rPr lang="en-US" dirty="0" err="1"/>
+              <a:t>l’api</a:t>
+            </a:r>
+            <a:r>
+              <a:rPr lang="en-US" dirty="0"/>
+              <a:t> </a:t>
+            </a:r>
+            <a:r>
+              <a:rPr lang="en-US" dirty="0" err="1"/>
+              <a:t>déployée</a:t>
+            </a:r>
+            <a:r>
+              <a:rPr lang="en-US" dirty="0"/>
+              <a:t> et je </a:t>
+            </a:r>
+            <a:r>
+              <a:rPr lang="en-US" dirty="0" err="1"/>
+              <a:t>terminerai</a:t>
+            </a:r>
+            <a:r>
+              <a:rPr lang="en-US" dirty="0"/>
+              <a:t> </a:t>
+            </a:r>
+            <a:r>
+              <a:rPr lang="en-US" dirty="0" err="1"/>
+              <a:t>en</a:t>
+            </a:r>
+            <a:r>
+              <a:rPr lang="en-US" dirty="0"/>
+              <a:t> </a:t>
+            </a:r>
+            <a:r>
+              <a:rPr lang="en-US" dirty="0" err="1"/>
+              <a:t>présentant</a:t>
+            </a:r>
+            <a:r>
+              <a:rPr lang="en-US" dirty="0"/>
+              <a:t> </a:t>
+            </a:r>
+            <a:r>
+              <a:rPr lang="en-US" dirty="0" err="1"/>
+              <a:t>mes</a:t>
+            </a:r>
+            <a:r>
+              <a:rPr lang="en-US" dirty="0"/>
+              <a:t> </a:t>
+            </a:r>
+            <a:r>
+              <a:rPr lang="en-US" dirty="0" err="1"/>
+              <a:t>résultats</a:t>
+            </a:r>
+            <a:r>
+              <a:rPr lang="en-US" dirty="0"/>
+              <a:t> de monitoring et </a:t>
+            </a:r>
+            <a:r>
+              <a:rPr lang="en-US" dirty="0" err="1"/>
+              <a:t>l’optimization</a:t>
+            </a:r>
+            <a:r>
+              <a:rPr lang="en-US" dirty="0"/>
+              <a:t> de </a:t>
+            </a:r>
+            <a:r>
+              <a:rPr lang="en-US" dirty="0" err="1"/>
+              <a:t>mon</a:t>
+            </a:r>
+            <a:r>
+              <a:rPr lang="en-US" dirty="0"/>
+              <a:t> pipeline de </a:t>
+            </a:r>
+            <a:r>
+              <a:rPr lang="en-US" dirty="0" err="1"/>
+              <a:t>requête</a:t>
+            </a:r>
+            <a:r>
+              <a:rPr lang="en-US" dirty="0"/>
+              <a:t>.  </a:t>
+            </a:r>
           </a:p>
         </p:txBody>
       </p:sp>
@@ -1216,7 +1557,218 @@
           <a:bodyPr/>
           <a:lstStyle/>
           <a:p>
-            <a:endParaRPr lang="en-US" dirty="0"/>
+            <a:r>
+              <a:rPr lang="en-US" dirty="0"/>
+              <a:t>La mission du </a:t>
+            </a:r>
+            <a:r>
+              <a:rPr lang="en-US" dirty="0" err="1"/>
+              <a:t>projet</a:t>
+            </a:r>
+            <a:r>
+              <a:rPr lang="en-US" dirty="0"/>
+              <a:t> </a:t>
+            </a:r>
+            <a:r>
+              <a:rPr lang="en-US" dirty="0" err="1"/>
+              <a:t>était</a:t>
+            </a:r>
+            <a:r>
+              <a:rPr lang="en-US" dirty="0"/>
+              <a:t> de </a:t>
+            </a:r>
+            <a:r>
+              <a:rPr lang="en-US" dirty="0" err="1"/>
+              <a:t>simuler</a:t>
+            </a:r>
+            <a:r>
+              <a:rPr lang="en-US" dirty="0"/>
+              <a:t> la mise </a:t>
+            </a:r>
+            <a:r>
+              <a:rPr lang="en-US" dirty="0" err="1"/>
+              <a:t>en</a:t>
+            </a:r>
+            <a:r>
+              <a:rPr lang="en-US" dirty="0"/>
+              <a:t> production d’un </a:t>
+            </a:r>
+            <a:r>
+              <a:rPr lang="en-US" dirty="0" err="1"/>
+              <a:t>modèle</a:t>
+            </a:r>
+            <a:r>
+              <a:rPr lang="en-US" dirty="0"/>
+              <a:t> de scoring client qui se base sur des données </a:t>
+            </a:r>
+            <a:r>
+              <a:rPr lang="en-US" dirty="0" err="1"/>
+              <a:t>bancaires</a:t>
+            </a:r>
+            <a:r>
+              <a:rPr lang="en-US" dirty="0"/>
+              <a:t> et </a:t>
+            </a:r>
+            <a:r>
+              <a:rPr lang="en-US" dirty="0" err="1"/>
+              <a:t>personnelles</a:t>
+            </a:r>
+            <a:r>
+              <a:rPr lang="en-US" dirty="0"/>
+              <a:t> pour </a:t>
+            </a:r>
+            <a:r>
+              <a:rPr lang="en-US" dirty="0" err="1"/>
+              <a:t>prédire</a:t>
+            </a:r>
+            <a:r>
+              <a:rPr lang="en-US" dirty="0"/>
+              <a:t> le </a:t>
+            </a:r>
+            <a:r>
+              <a:rPr lang="en-US" dirty="0" err="1"/>
+              <a:t>recouvrement</a:t>
+            </a:r>
+            <a:r>
+              <a:rPr lang="en-US" dirty="0"/>
+              <a:t> d’un nouveau prêt. Les deux </a:t>
+            </a:r>
+            <a:r>
+              <a:rPr lang="en-US" dirty="0" err="1"/>
+              <a:t>objectifs</a:t>
+            </a:r>
+            <a:r>
+              <a:rPr lang="en-US" dirty="0"/>
+              <a:t> </a:t>
+            </a:r>
+            <a:r>
+              <a:rPr lang="en-US" dirty="0" err="1"/>
+              <a:t>principaux</a:t>
+            </a:r>
+            <a:r>
+              <a:rPr lang="en-US" dirty="0"/>
+              <a:t> </a:t>
+            </a:r>
+            <a:r>
+              <a:rPr lang="en-US" dirty="0" err="1"/>
+              <a:t>étaient</a:t>
+            </a:r>
+            <a:r>
+              <a:rPr lang="en-US" dirty="0"/>
+              <a:t> le </a:t>
+            </a:r>
+            <a:r>
+              <a:rPr lang="en-US" dirty="0" err="1"/>
+              <a:t>déploiement</a:t>
+            </a:r>
+            <a:r>
+              <a:rPr lang="en-US" dirty="0"/>
+              <a:t> </a:t>
+            </a:r>
+            <a:r>
+              <a:rPr lang="en-US" dirty="0" err="1"/>
+              <a:t>d’une</a:t>
+            </a:r>
+            <a:r>
+              <a:rPr lang="en-US" dirty="0"/>
+              <a:t> API </a:t>
+            </a:r>
+            <a:r>
+              <a:rPr lang="en-US" dirty="0" err="1"/>
+              <a:t>gradio</a:t>
+            </a:r>
+            <a:r>
+              <a:rPr lang="en-US" dirty="0"/>
+              <a:t> </a:t>
+            </a:r>
+            <a:r>
+              <a:rPr lang="en-US" dirty="0" err="1"/>
+              <a:t>conteneurisée</a:t>
+            </a:r>
+            <a:r>
+              <a:rPr lang="en-US" dirty="0"/>
+              <a:t> sur </a:t>
+            </a:r>
+            <a:r>
+              <a:rPr lang="en-US" dirty="0" err="1"/>
+              <a:t>une</a:t>
+            </a:r>
+            <a:r>
+              <a:rPr lang="en-US" dirty="0"/>
+              <a:t> </a:t>
+            </a:r>
+            <a:r>
+              <a:rPr lang="en-US" dirty="0" err="1"/>
+              <a:t>plateforme</a:t>
+            </a:r>
+            <a:r>
+              <a:rPr lang="en-US" dirty="0"/>
+              <a:t> </a:t>
+            </a:r>
+            <a:r>
+              <a:rPr lang="en-US" dirty="0" err="1"/>
+              <a:t>permettant</a:t>
+            </a:r>
+            <a:r>
+              <a:rPr lang="en-US" dirty="0"/>
+              <a:t> </a:t>
+            </a:r>
+            <a:r>
+              <a:rPr lang="en-US" dirty="0" err="1"/>
+              <a:t>d’utilizer</a:t>
+            </a:r>
+            <a:r>
+              <a:rPr lang="en-US" dirty="0"/>
+              <a:t> </a:t>
+            </a:r>
+            <a:r>
+              <a:rPr lang="en-US" dirty="0" err="1"/>
+              <a:t>l’application</a:t>
+            </a:r>
+            <a:r>
+              <a:rPr lang="en-US" dirty="0"/>
+              <a:t> et la mise </a:t>
+            </a:r>
+            <a:r>
+              <a:rPr lang="en-US" dirty="0" err="1"/>
+              <a:t>en</a:t>
+            </a:r>
+            <a:r>
+              <a:rPr lang="en-US" dirty="0"/>
+              <a:t> place d’un dashboard de monitoring de </a:t>
+            </a:r>
+            <a:r>
+              <a:rPr lang="en-US" dirty="0" err="1"/>
+              <a:t>l’API</a:t>
+            </a:r>
+            <a:r>
+              <a:rPr lang="en-US" dirty="0"/>
+              <a:t> qui </a:t>
+            </a:r>
+            <a:r>
+              <a:rPr lang="en-US" dirty="0" err="1"/>
+              <a:t>permet</a:t>
+            </a:r>
+            <a:r>
+              <a:rPr lang="en-US" dirty="0"/>
+              <a:t> de </a:t>
+            </a:r>
+            <a:r>
+              <a:rPr lang="en-US" dirty="0" err="1"/>
+              <a:t>suivre</a:t>
+            </a:r>
+            <a:r>
+              <a:rPr lang="en-US" dirty="0"/>
+              <a:t> son </a:t>
+            </a:r>
+            <a:r>
+              <a:rPr lang="en-US" dirty="0" err="1"/>
+              <a:t>fonctionnement</a:t>
+            </a:r>
+            <a:r>
+              <a:rPr lang="en-US" dirty="0"/>
+              <a:t>.</a:t>
+            </a:r>
           </a:p>
         </p:txBody>
       </p:sp>
@@ -1306,7 +1858,466 @@
           <a:bodyPr/>
           <a:lstStyle/>
           <a:p>
-            <a:endParaRPr lang="en-US" dirty="0"/>
+            <a:r>
+              <a:rPr lang="en-US" dirty="0"/>
+              <a:t>Pour </a:t>
+            </a:r>
+            <a:r>
+              <a:rPr lang="en-US" dirty="0" err="1"/>
+              <a:t>ce</a:t>
+            </a:r>
+            <a:r>
+              <a:rPr lang="en-US" dirty="0"/>
+              <a:t> qui est de </a:t>
+            </a:r>
+            <a:r>
+              <a:rPr lang="en-US" dirty="0" err="1"/>
+              <a:t>l’organization</a:t>
+            </a:r>
+            <a:r>
+              <a:rPr lang="en-US" dirty="0"/>
+              <a:t> de </a:t>
+            </a:r>
+            <a:r>
+              <a:rPr lang="en-US" dirty="0" err="1"/>
+              <a:t>mon</a:t>
+            </a:r>
+            <a:r>
+              <a:rPr lang="en-US" dirty="0"/>
+              <a:t> depot, je vous </a:t>
+            </a:r>
+            <a:r>
+              <a:rPr lang="en-US" dirty="0" err="1"/>
+              <a:t>présente</a:t>
+            </a:r>
+            <a:r>
+              <a:rPr lang="en-US" dirty="0"/>
+              <a:t> </a:t>
+            </a:r>
+            <a:r>
+              <a:rPr lang="en-US" dirty="0" err="1"/>
+              <a:t>ici</a:t>
+            </a:r>
+            <a:r>
+              <a:rPr lang="en-US" dirty="0"/>
+              <a:t> </a:t>
+            </a:r>
+            <a:r>
+              <a:rPr lang="en-US" dirty="0" err="1"/>
+              <a:t>l’architecture</a:t>
+            </a:r>
+            <a:r>
+              <a:rPr lang="en-US" dirty="0"/>
+              <a:t> de </a:t>
+            </a:r>
+            <a:r>
+              <a:rPr lang="en-US" dirty="0" err="1"/>
+              <a:t>mon</a:t>
+            </a:r>
+            <a:r>
+              <a:rPr lang="en-US" dirty="0"/>
+              <a:t> </a:t>
+            </a:r>
+            <a:r>
+              <a:rPr lang="en-US" dirty="0" err="1"/>
+              <a:t>projet</a:t>
+            </a:r>
+            <a:r>
+              <a:rPr lang="en-US" dirty="0"/>
+              <a:t>. </a:t>
+            </a:r>
+            <a:r>
+              <a:rPr lang="en-US" dirty="0" err="1"/>
+              <a:t>J’ai</a:t>
+            </a:r>
+            <a:r>
+              <a:rPr lang="en-US" dirty="0"/>
+              <a:t> 4 </a:t>
+            </a:r>
+            <a:r>
+              <a:rPr lang="en-US" dirty="0" err="1"/>
+              <a:t>éléments</a:t>
+            </a:r>
+            <a:r>
+              <a:rPr lang="en-US" dirty="0"/>
+              <a:t> à la </a:t>
+            </a:r>
+            <a:r>
+              <a:rPr lang="en-US" dirty="0" err="1"/>
+              <a:t>racine</a:t>
+            </a:r>
+            <a:r>
+              <a:rPr lang="en-US" dirty="0"/>
+              <a:t>, un dossier source qui </a:t>
+            </a:r>
+            <a:r>
+              <a:rPr lang="en-US" dirty="0" err="1"/>
+              <a:t>va</a:t>
+            </a:r>
+            <a:r>
+              <a:rPr lang="en-US" dirty="0"/>
+              <a:t> </a:t>
+            </a:r>
+            <a:r>
+              <a:rPr lang="en-US" dirty="0" err="1"/>
+              <a:t>contenir</a:t>
+            </a:r>
+            <a:r>
+              <a:rPr lang="en-US" dirty="0"/>
+              <a:t> la </a:t>
+            </a:r>
+            <a:r>
+              <a:rPr lang="en-US" dirty="0" err="1"/>
+              <a:t>totalité</a:t>
+            </a:r>
+            <a:r>
+              <a:rPr lang="en-US" dirty="0"/>
+              <a:t> de </a:t>
+            </a:r>
+            <a:r>
+              <a:rPr lang="en-US" dirty="0" err="1"/>
+              <a:t>mon</a:t>
+            </a:r>
+            <a:r>
+              <a:rPr lang="en-US" dirty="0"/>
+              <a:t> code. Un dossier data, qui </a:t>
+            </a:r>
+            <a:r>
+              <a:rPr lang="en-US" dirty="0" err="1"/>
+              <a:t>contient</a:t>
+            </a:r>
+            <a:r>
+              <a:rPr lang="en-US" dirty="0"/>
+              <a:t> </a:t>
+            </a:r>
+            <a:r>
+              <a:rPr lang="en-US" dirty="0" err="1"/>
+              <a:t>une</a:t>
+            </a:r>
+            <a:r>
+              <a:rPr lang="en-US" dirty="0"/>
+              <a:t> </a:t>
+            </a:r>
+            <a:r>
+              <a:rPr lang="en-US" dirty="0" err="1"/>
+              <a:t>partie</a:t>
+            </a:r>
+            <a:r>
+              <a:rPr lang="en-US" dirty="0"/>
+              <a:t> des données </a:t>
+            </a:r>
+            <a:r>
+              <a:rPr lang="en-US" dirty="0" err="1"/>
+              <a:t>d’entrainement</a:t>
+            </a:r>
+            <a:r>
+              <a:rPr lang="en-US" dirty="0"/>
+              <a:t> du </a:t>
+            </a:r>
+            <a:r>
+              <a:rPr lang="en-US" dirty="0" err="1"/>
+              <a:t>modèle</a:t>
+            </a:r>
+            <a:r>
+              <a:rPr lang="en-US" dirty="0"/>
+              <a:t> </a:t>
+            </a:r>
+            <a:r>
+              <a:rPr lang="en-US" dirty="0" err="1"/>
+              <a:t>comme</a:t>
+            </a:r>
+            <a:r>
+              <a:rPr lang="en-US" dirty="0"/>
+              <a:t> données de demonstration. Ce tableau me </a:t>
+            </a:r>
+            <a:r>
+              <a:rPr lang="en-US" dirty="0" err="1"/>
+              <a:t>permet</a:t>
+            </a:r>
+            <a:r>
+              <a:rPr lang="en-US" dirty="0"/>
+              <a:t> de </a:t>
+            </a:r>
+            <a:r>
+              <a:rPr lang="en-US" dirty="0" err="1"/>
+              <a:t>récupérer</a:t>
+            </a:r>
+            <a:r>
+              <a:rPr lang="en-US" dirty="0"/>
+              <a:t> les features et de </a:t>
+            </a:r>
+            <a:r>
+              <a:rPr lang="en-US" dirty="0" err="1"/>
+              <a:t>simuler</a:t>
+            </a:r>
+            <a:r>
+              <a:rPr lang="en-US" dirty="0"/>
+              <a:t> de nouveau </a:t>
+            </a:r>
+            <a:r>
+              <a:rPr lang="en-US" dirty="0" err="1"/>
+              <a:t>profil</a:t>
+            </a:r>
+            <a:r>
+              <a:rPr lang="en-US" dirty="0"/>
+              <a:t> de données </a:t>
+            </a:r>
+            <a:r>
+              <a:rPr lang="en-US" dirty="0" err="1"/>
+              <a:t>en</a:t>
+            </a:r>
+            <a:r>
+              <a:rPr lang="en-US" dirty="0"/>
+              <a:t> y </a:t>
+            </a:r>
+            <a:r>
+              <a:rPr lang="en-US" dirty="0" err="1"/>
+              <a:t>piochant</a:t>
+            </a:r>
+            <a:r>
+              <a:rPr lang="en-US" dirty="0"/>
+              <a:t> des </a:t>
+            </a:r>
+            <a:r>
+              <a:rPr lang="en-US" dirty="0" err="1"/>
+              <a:t>valeurs</a:t>
+            </a:r>
+            <a:r>
+              <a:rPr lang="en-US" dirty="0"/>
+              <a:t>. Le dossier schema </a:t>
+            </a:r>
+            <a:r>
+              <a:rPr lang="en-US" dirty="0" err="1"/>
+              <a:t>contient</a:t>
+            </a:r>
+            <a:r>
+              <a:rPr lang="en-US" dirty="0"/>
+              <a:t> les </a:t>
+            </a:r>
+            <a:r>
+              <a:rPr lang="en-US" dirty="0" err="1"/>
+              <a:t>schémas</a:t>
+            </a:r>
+            <a:r>
+              <a:rPr lang="en-US" dirty="0"/>
+              <a:t> de validation </a:t>
+            </a:r>
+            <a:r>
+              <a:rPr lang="en-US" dirty="0" err="1"/>
+              <a:t>pydantic</a:t>
+            </a:r>
+            <a:r>
+              <a:rPr lang="en-US" dirty="0"/>
+              <a:t> sous la </a:t>
+            </a:r>
+            <a:r>
+              <a:rPr lang="en-US" dirty="0" err="1"/>
+              <a:t>forme</a:t>
+            </a:r>
+            <a:r>
+              <a:rPr lang="en-US" dirty="0"/>
+              <a:t> d’un </a:t>
+            </a:r>
+            <a:r>
+              <a:rPr lang="en-US" dirty="0" err="1"/>
+              <a:t>json</a:t>
+            </a:r>
+            <a:r>
+              <a:rPr lang="en-US" dirty="0"/>
+              <a:t> pour la verification des features </a:t>
+            </a:r>
+            <a:r>
+              <a:rPr lang="en-US" dirty="0" err="1"/>
+              <a:t>requêtées</a:t>
+            </a:r>
+            <a:r>
+              <a:rPr lang="en-US" dirty="0"/>
+              <a:t> par le client. Ensuite, un dossier outputs pour le stockage de </a:t>
+            </a:r>
+            <a:r>
+              <a:rPr lang="en-US" dirty="0" err="1"/>
+              <a:t>graphiques</a:t>
+            </a:r>
+            <a:r>
+              <a:rPr lang="en-US" dirty="0"/>
+              <a:t>, un </a:t>
+            </a:r>
+            <a:r>
+              <a:rPr lang="en-US" dirty="0" err="1"/>
+              <a:t>dokerfile</a:t>
+            </a:r>
+            <a:r>
+              <a:rPr lang="en-US" dirty="0"/>
+              <a:t> pour les instructions de </a:t>
+            </a:r>
+            <a:r>
+              <a:rPr lang="en-US" dirty="0" err="1"/>
+              <a:t>conteneurisation</a:t>
+            </a:r>
+            <a:r>
+              <a:rPr lang="en-US" dirty="0"/>
+              <a:t> et le schema de </a:t>
+            </a:r>
+            <a:r>
+              <a:rPr lang="en-US" dirty="0" err="1"/>
+              <a:t>mon</a:t>
+            </a:r>
+            <a:r>
+              <a:rPr lang="en-US" dirty="0"/>
+              <a:t> Environnement </a:t>
+            </a:r>
+            <a:r>
+              <a:rPr lang="en-US" dirty="0" err="1"/>
+              <a:t>virtuel</a:t>
+            </a:r>
+            <a:r>
+              <a:rPr lang="en-US" dirty="0"/>
+              <a:t> sous la </a:t>
+            </a:r>
+            <a:r>
+              <a:rPr lang="en-US" dirty="0" err="1"/>
+              <a:t>forme</a:t>
+            </a:r>
+            <a:r>
+              <a:rPr lang="en-US" dirty="0"/>
+              <a:t> d’un </a:t>
+            </a:r>
+            <a:r>
+              <a:rPr lang="en-US" dirty="0" err="1"/>
+              <a:t>fichier</a:t>
+            </a:r>
+            <a:r>
+              <a:rPr lang="en-US" dirty="0"/>
+              <a:t> </a:t>
+            </a:r>
+            <a:r>
+              <a:rPr lang="en-US" dirty="0" err="1"/>
+              <a:t>toml</a:t>
+            </a:r>
+            <a:r>
+              <a:rPr lang="en-US" dirty="0"/>
+              <a:t>. </a:t>
+            </a:r>
+            <a:r>
+              <a:rPr lang="en-US" dirty="0" err="1"/>
+              <a:t>J’utilize</a:t>
+            </a:r>
+            <a:r>
+              <a:rPr lang="en-US" dirty="0"/>
+              <a:t> </a:t>
+            </a:r>
+            <a:r>
+              <a:rPr lang="en-US" dirty="0" err="1"/>
+              <a:t>uv</a:t>
+            </a:r>
+            <a:r>
+              <a:rPr lang="en-US" dirty="0"/>
+              <a:t> pour </a:t>
+            </a:r>
+            <a:r>
+              <a:rPr lang="en-US" dirty="0" err="1"/>
+              <a:t>gérer</a:t>
+            </a:r>
+            <a:r>
+              <a:rPr lang="en-US" dirty="0"/>
+              <a:t> </a:t>
+            </a:r>
+            <a:r>
+              <a:rPr lang="en-US" dirty="0" err="1"/>
+              <a:t>mon</a:t>
+            </a:r>
+            <a:r>
+              <a:rPr lang="en-US" dirty="0"/>
+              <a:t> Environnement. Dans le dossier source on </a:t>
+            </a:r>
+            <a:r>
+              <a:rPr lang="en-US" dirty="0" err="1"/>
+              <a:t>retrouvera</a:t>
+            </a:r>
+            <a:r>
+              <a:rPr lang="en-US" dirty="0"/>
+              <a:t>: les scripts de </a:t>
+            </a:r>
+            <a:r>
+              <a:rPr lang="en-US" dirty="0" err="1"/>
+              <a:t>l’api</a:t>
+            </a:r>
+            <a:r>
+              <a:rPr lang="en-US" dirty="0"/>
+              <a:t>; de la gestion de la base de données; du dashboard de monitoring; le </a:t>
+            </a:r>
+            <a:r>
+              <a:rPr lang="en-US" dirty="0" err="1"/>
+              <a:t>modèle</a:t>
+            </a:r>
+            <a:r>
+              <a:rPr lang="en-US" dirty="0"/>
+              <a:t> et </a:t>
+            </a:r>
+            <a:r>
+              <a:rPr lang="en-US" dirty="0" err="1"/>
+              <a:t>ses</a:t>
+            </a:r>
+            <a:r>
+              <a:rPr lang="en-US" dirty="0"/>
+              <a:t> </a:t>
+            </a:r>
+            <a:r>
+              <a:rPr lang="en-US" dirty="0" err="1"/>
+              <a:t>utilitaires</a:t>
+            </a:r>
+            <a:r>
+              <a:rPr lang="en-US" dirty="0"/>
+              <a:t>; </a:t>
+            </a:r>
+            <a:r>
+              <a:rPr lang="en-US" dirty="0" err="1"/>
+              <a:t>plusieurs</a:t>
+            </a:r>
+            <a:r>
+              <a:rPr lang="en-US" dirty="0"/>
+              <a:t> notebook pour </a:t>
+            </a:r>
+            <a:r>
+              <a:rPr lang="en-US" dirty="0" err="1"/>
+              <a:t>l’exploration</a:t>
+            </a:r>
+            <a:r>
+              <a:rPr lang="en-US" dirty="0"/>
+              <a:t> des données, la creation de la base et le travail </a:t>
+            </a:r>
+            <a:r>
+              <a:rPr lang="en-US" dirty="0" err="1"/>
+              <a:t>d’optimization</a:t>
+            </a:r>
+            <a:r>
+              <a:rPr lang="en-US" dirty="0"/>
+              <a:t>; et pour </a:t>
+            </a:r>
+            <a:r>
+              <a:rPr lang="en-US" dirty="0" err="1"/>
+              <a:t>finir</a:t>
+            </a:r>
+            <a:r>
+              <a:rPr lang="en-US" dirty="0"/>
+              <a:t> les tests </a:t>
+            </a:r>
+            <a:r>
+              <a:rPr lang="en-US" dirty="0" err="1"/>
+              <a:t>unitaires</a:t>
+            </a:r>
+            <a:r>
+              <a:rPr lang="en-US" dirty="0"/>
+              <a:t> et </a:t>
+            </a:r>
+            <a:r>
+              <a:rPr lang="en-US" dirty="0" err="1"/>
+              <a:t>d’integration</a:t>
+            </a:r>
+            <a:r>
+              <a:rPr lang="en-US" dirty="0"/>
+              <a:t>.</a:t>
+            </a:r>
           </a:p>
         </p:txBody>
       </p:sp>
@@ -1390,7 +2401,58 @@
           <a:bodyPr/>
           <a:lstStyle/>
           <a:p>
-            <a:endParaRPr lang="fr-FR" dirty="0"/>
+            <a:r>
+              <a:rPr lang="fr-FR" dirty="0"/>
+              <a:t>Ici c’est un </a:t>
+            </a:r>
+            <a:r>
+              <a:rPr lang="fr-FR" dirty="0" err="1"/>
+              <a:t>schema</a:t>
+            </a:r>
+            <a:r>
+              <a:rPr lang="fr-FR" dirty="0"/>
+              <a:t> de mon flux de travail avec git. Il ne s’agit pas de la totalité de mon </a:t>
+            </a:r>
+            <a:r>
+              <a:rPr lang="fr-FR" dirty="0" err="1"/>
+              <a:t>schema</a:t>
+            </a:r>
+            <a:r>
+              <a:rPr lang="fr-FR" dirty="0"/>
+              <a:t> de branches  mais seulement d’une partie pour pouvoir illustrer ma méthode. Donc c’est une version simplifiée de la méthode </a:t>
+            </a:r>
+            <a:r>
+              <a:rPr lang="fr-FR" dirty="0" err="1"/>
+              <a:t>gitflow</a:t>
+            </a:r>
+            <a:r>
+              <a:rPr lang="fr-FR" dirty="0"/>
+              <a:t> avec une branche principale de développement, donc dev, de laquelle partent des branches de fonctionnalités spécifiques qui me permettent de développer c’est fonctionnalité sans risque de casser le code principal. Une fois la fonctionnalité terminée, la branche est mergée sur dev avec le contrôle de mon pipeline d’intégration continue pour assurer la qualité du code. Puis de dev, je fais des releases sur la branche de production avec une ou plusieurs nouvelles </a:t>
+            </a:r>
+            <a:r>
+              <a:rPr lang="fr-FR" dirty="0" err="1"/>
+              <a:t>features</a:t>
+            </a:r>
+            <a:r>
+              <a:rPr lang="fr-FR" dirty="0"/>
+              <a:t>. Chaque nouvelle release est taguée. A chaque poussée sur production, mon pipeline de déploiement continue publie l’application sur </a:t>
+            </a:r>
+            <a:r>
+              <a:rPr lang="fr-FR" dirty="0" err="1"/>
+              <a:t>huggingface</a:t>
+            </a:r>
+            <a:r>
+              <a:rPr lang="fr-FR" dirty="0"/>
+              <a:t> </a:t>
+            </a:r>
+            <a:r>
+              <a:rPr lang="fr-FR" dirty="0" err="1"/>
+              <a:t>spaces</a:t>
+            </a:r>
+            <a:r>
+              <a:rPr lang="fr-FR" dirty="0"/>
+              <a:t>.</a:t>
+            </a:r>
           </a:p>
         </p:txBody>
       </p:sp>
@@ -1492,7 +2554,62 @@
           <a:bodyPr/>
           <a:lstStyle/>
           <a:p>
-            <a:endParaRPr lang="en-US" dirty="0"/>
+            <a:r>
+              <a:rPr lang="en-US" dirty="0" err="1"/>
+              <a:t>Donc</a:t>
+            </a:r>
+            <a:r>
+              <a:rPr lang="en-US" dirty="0"/>
+              <a:t> je </a:t>
+            </a:r>
+            <a:r>
+              <a:rPr lang="en-US" dirty="0" err="1"/>
+              <a:t>vais</a:t>
+            </a:r>
+            <a:r>
+              <a:rPr lang="en-US" dirty="0"/>
+              <a:t> vous faire la demonstration du </a:t>
+            </a:r>
+            <a:r>
+              <a:rPr lang="en-US" dirty="0" err="1"/>
+              <a:t>fonctionnement</a:t>
+            </a:r>
+            <a:r>
+              <a:rPr lang="en-US" dirty="0"/>
+              <a:t> de </a:t>
+            </a:r>
+            <a:r>
+              <a:rPr lang="en-US" dirty="0" err="1"/>
+              <a:t>mon</a:t>
+            </a:r>
+            <a:r>
+              <a:rPr lang="en-US" dirty="0"/>
+              <a:t> </a:t>
+            </a:r>
+            <a:r>
+              <a:rPr lang="en-US" dirty="0" err="1"/>
+              <a:t>api</a:t>
+            </a:r>
+            <a:r>
+              <a:rPr lang="en-US" dirty="0"/>
+              <a:t> </a:t>
+            </a:r>
+            <a:r>
+              <a:rPr lang="en-US" dirty="0" err="1"/>
+              <a:t>déployée</a:t>
+            </a:r>
+            <a:r>
+              <a:rPr lang="en-US" dirty="0"/>
+              <a:t> et de </a:t>
+            </a:r>
+            <a:r>
+              <a:rPr lang="en-US" dirty="0" err="1"/>
+              <a:t>mon</a:t>
+            </a:r>
+            <a:r>
+              <a:rPr lang="en-US" dirty="0"/>
+              <a:t> pipeline de ci/cd</a:t>
+            </a:r>
           </a:p>
         </p:txBody>
       </p:sp>
@@ -1600,7 +2717,50 @@
           <a:bodyPr/>
           <a:lstStyle/>
           <a:p>
-            <a:endParaRPr lang="en-US" dirty="0"/>
+            <a:r>
+              <a:rPr lang="en-US" dirty="0"/>
+              <a:t>Je </a:t>
+            </a:r>
+            <a:r>
+              <a:rPr lang="en-US" dirty="0" err="1"/>
+              <a:t>terminerai</a:t>
+            </a:r>
+            <a:r>
+              <a:rPr lang="en-US" dirty="0"/>
+              <a:t> avec les </a:t>
+            </a:r>
+            <a:r>
+              <a:rPr lang="en-US" dirty="0" err="1"/>
+              <a:t>résultats</a:t>
+            </a:r>
+            <a:r>
+              <a:rPr lang="en-US" dirty="0"/>
+              <a:t> du monitoring de </a:t>
+            </a:r>
+            <a:r>
+              <a:rPr lang="en-US" dirty="0" err="1"/>
+              <a:t>l’api</a:t>
+            </a:r>
+            <a:r>
+              <a:rPr lang="en-US" dirty="0"/>
+              <a:t> à </a:t>
+            </a:r>
+            <a:r>
+              <a:rPr lang="en-US" dirty="0" err="1"/>
+              <a:t>partir</a:t>
+            </a:r>
+            <a:r>
+              <a:rPr lang="en-US" dirty="0"/>
+              <a:t> de données </a:t>
+            </a:r>
+            <a:r>
+              <a:rPr lang="en-US" dirty="0" err="1"/>
+              <a:t>simulée</a:t>
+            </a:r>
+            <a:r>
+              <a:rPr lang="en-US" dirty="0"/>
+              <a:t>. </a:t>
+            </a:r>
           </a:p>
         </p:txBody>
       </p:sp>
@@ -1708,7 +2868,98 @@
           <a:bodyPr/>
           <a:lstStyle/>
           <a:p>
-            <a:endParaRPr lang="en-US" dirty="0"/>
+            <a:r>
+              <a:rPr lang="en-US" dirty="0"/>
+              <a:t>La durée Moyenne de </a:t>
+            </a:r>
+            <a:r>
+              <a:rPr lang="en-US" dirty="0" err="1"/>
+              <a:t>mes</a:t>
+            </a:r>
+            <a:r>
+              <a:rPr lang="en-US" dirty="0"/>
+              <a:t> </a:t>
+            </a:r>
+            <a:r>
+              <a:rPr lang="en-US" dirty="0" err="1"/>
+              <a:t>requêtes</a:t>
+            </a:r>
+            <a:r>
+              <a:rPr lang="en-US" dirty="0"/>
+              <a:t> et de 31ms, don’t 71% du temps pris par </a:t>
+            </a:r>
+            <a:r>
+              <a:rPr lang="en-US" dirty="0" err="1"/>
+              <a:t>l’étape</a:t>
+            </a:r>
+            <a:r>
+              <a:rPr lang="en-US" dirty="0"/>
+              <a:t> </a:t>
+            </a:r>
+            <a:r>
+              <a:rPr lang="en-US" dirty="0" err="1"/>
+              <a:t>d’inference</a:t>
+            </a:r>
+            <a:r>
+              <a:rPr lang="en-US" dirty="0"/>
+              <a:t>. Pour identifier les </a:t>
+            </a:r>
+            <a:r>
+              <a:rPr lang="en-US" dirty="0" err="1"/>
+              <a:t>fonctions</a:t>
+            </a:r>
+            <a:r>
+              <a:rPr lang="en-US" dirty="0"/>
+              <a:t> qui font </a:t>
+            </a:r>
+            <a:r>
+              <a:rPr lang="en-US" dirty="0" err="1"/>
+              <a:t>goulots</a:t>
+            </a:r>
+            <a:r>
+              <a:rPr lang="en-US" dirty="0"/>
+              <a:t> </a:t>
+            </a:r>
+            <a:r>
+              <a:rPr lang="en-US" dirty="0" err="1"/>
+              <a:t>d’étranglement</a:t>
+            </a:r>
+            <a:r>
+              <a:rPr lang="en-US" dirty="0"/>
+              <a:t> de </a:t>
+            </a:r>
+            <a:r>
+              <a:rPr lang="en-US" dirty="0" err="1"/>
+              <a:t>mon</a:t>
+            </a:r>
+            <a:r>
+              <a:rPr lang="en-US" dirty="0"/>
+              <a:t> pipeline de </a:t>
+            </a:r>
+            <a:r>
+              <a:rPr lang="en-US" dirty="0" err="1"/>
+              <a:t>requête</a:t>
+            </a:r>
+            <a:r>
+              <a:rPr lang="en-US" dirty="0"/>
+              <a:t> </a:t>
+            </a:r>
+            <a:r>
+              <a:rPr lang="en-US" dirty="0" err="1"/>
+              <a:t>j’utilize</a:t>
+            </a:r>
+            <a:r>
+              <a:rPr lang="en-US" dirty="0"/>
+              <a:t> </a:t>
+            </a:r>
+            <a:r>
+              <a:rPr lang="en-US" dirty="0" err="1"/>
+              <a:t>cProfile</a:t>
+            </a:r>
+            <a:r>
+              <a:rPr lang="en-US" dirty="0"/>
+              <a:t>.</a:t>
+            </a:r>
           </a:p>
         </p:txBody>
       </p:sp>
@@ -1816,7 +3067,162 @@
           <a:bodyPr/>
           <a:lstStyle/>
           <a:p>
-            <a:endParaRPr lang="en-US" dirty="0"/>
+            <a:r>
+              <a:rPr lang="en-US" dirty="0"/>
+              <a:t>Ca me </a:t>
+            </a:r>
+            <a:r>
+              <a:rPr lang="en-US" dirty="0" err="1"/>
+              <a:t>permet</a:t>
+            </a:r>
+            <a:r>
+              <a:rPr lang="en-US" dirty="0"/>
+              <a:t> de </a:t>
+            </a:r>
+            <a:r>
+              <a:rPr lang="en-US" dirty="0" err="1"/>
+              <a:t>mettre</a:t>
+            </a:r>
+            <a:r>
+              <a:rPr lang="en-US" dirty="0"/>
+              <a:t> </a:t>
+            </a:r>
+            <a:r>
+              <a:rPr lang="en-US" dirty="0" err="1"/>
+              <a:t>en</a:t>
+            </a:r>
+            <a:r>
+              <a:rPr lang="en-US" dirty="0"/>
+              <a:t> evidence </a:t>
+            </a:r>
+            <a:r>
+              <a:rPr lang="en-US" dirty="0" err="1"/>
+              <a:t>que</a:t>
+            </a:r>
+            <a:r>
+              <a:rPr lang="en-US" dirty="0"/>
+              <a:t> la function qui utilize la </a:t>
+            </a:r>
+            <a:r>
+              <a:rPr lang="en-US" dirty="0" err="1"/>
+              <a:t>majorité</a:t>
+            </a:r>
+            <a:r>
+              <a:rPr lang="en-US" dirty="0"/>
+              <a:t> du temps de </a:t>
+            </a:r>
+            <a:r>
+              <a:rPr lang="en-US" dirty="0" err="1"/>
+              <a:t>requête</a:t>
+            </a:r>
+            <a:r>
+              <a:rPr lang="en-US" dirty="0"/>
+              <a:t> et ma function </a:t>
+            </a:r>
+            <a:r>
+              <a:rPr lang="en-US" dirty="0" err="1"/>
+              <a:t>d’inference</a:t>
+            </a:r>
+            <a:r>
+              <a:rPr lang="en-US" dirty="0"/>
+              <a:t> </a:t>
+            </a:r>
+            <a:r>
+              <a:rPr lang="en-US" dirty="0" err="1"/>
+              <a:t>infer_from_new_vector</a:t>
+            </a:r>
+            <a:r>
+              <a:rPr lang="en-US" dirty="0"/>
+              <a:t> au sein de </a:t>
+            </a:r>
+            <a:r>
+              <a:rPr lang="en-US" dirty="0" err="1"/>
+              <a:t>laquelle</a:t>
+            </a:r>
+            <a:r>
+              <a:rPr lang="en-US" dirty="0"/>
+              <a:t> le plus </a:t>
+            </a:r>
+            <a:r>
+              <a:rPr lang="en-US" dirty="0" err="1"/>
+              <a:t>couteux</a:t>
+            </a:r>
+            <a:r>
+              <a:rPr lang="en-US" dirty="0"/>
+              <a:t> est </a:t>
+            </a:r>
+            <a:r>
+              <a:rPr lang="en-US" dirty="0" err="1"/>
+              <a:t>en</a:t>
+            </a:r>
+            <a:r>
+              <a:rPr lang="en-US" dirty="0"/>
+              <a:t> fait la function predict de scikit learn. Il est </a:t>
+            </a:r>
+            <a:r>
+              <a:rPr lang="en-US" dirty="0" err="1"/>
+              <a:t>donc</a:t>
+            </a:r>
+            <a:r>
+              <a:rPr lang="en-US" dirty="0"/>
+              <a:t> possible </a:t>
+            </a:r>
+            <a:r>
+              <a:rPr lang="en-US" dirty="0" err="1"/>
+              <a:t>d’optimizer</a:t>
+            </a:r>
+            <a:r>
+              <a:rPr lang="en-US" dirty="0"/>
+              <a:t> le pipeline </a:t>
+            </a:r>
+            <a:r>
+              <a:rPr lang="en-US" dirty="0" err="1"/>
+              <a:t>en</a:t>
+            </a:r>
+            <a:r>
+              <a:rPr lang="en-US" dirty="0"/>
+              <a:t> transformant le </a:t>
+            </a:r>
+            <a:r>
+              <a:rPr lang="en-US" dirty="0" err="1"/>
+              <a:t>modèle</a:t>
+            </a:r>
+            <a:r>
+              <a:rPr lang="en-US" dirty="0"/>
+              <a:t>. Pour </a:t>
+            </a:r>
+            <a:r>
+              <a:rPr lang="en-US" dirty="0" err="1"/>
+              <a:t>ça</a:t>
+            </a:r>
+            <a:r>
+              <a:rPr lang="en-US" dirty="0"/>
+              <a:t>, </a:t>
+            </a:r>
+            <a:r>
+              <a:rPr lang="en-US" dirty="0" err="1"/>
+              <a:t>j’ai</a:t>
+            </a:r>
+            <a:r>
+              <a:rPr lang="en-US" dirty="0"/>
+              <a:t> </a:t>
+            </a:r>
+            <a:r>
+              <a:rPr lang="en-US" dirty="0" err="1"/>
+              <a:t>utilisé</a:t>
+            </a:r>
+            <a:r>
+              <a:rPr lang="en-US" dirty="0"/>
+              <a:t> </a:t>
+            </a:r>
+            <a:r>
+              <a:rPr lang="en-US" dirty="0" err="1"/>
+              <a:t>onnx</a:t>
+            </a:r>
+            <a:r>
+              <a:rPr lang="en-US" dirty="0"/>
+              <a:t> runtime.</a:t>
+            </a:r>
           </a:p>
         </p:txBody>
       </p:sp>
@@ -2150,7 +3556,7 @@
           <a:p>
             <a:fld id="{D1F3894F-03A6-4760-8AFF-8C8908CB964C}" type="datetimeFigureOut">
               <a:rPr lang="en-US" smtClean="0"/>
-              <a:t>8/17/2026</a:t>
+              <a:t>8/22/2026</a:t>
             </a:fld>
             <a:endParaRPr lang="en-US"/>
           </a:p>
@@ -2564,7 +3970,7 @@
           <a:p>
             <a:fld id="{D1F3894F-03A6-4760-8AFF-8C8908CB964C}" type="datetimeFigureOut">
               <a:rPr lang="en-US" smtClean="0"/>
-              <a:t>8/17/2026</a:t>
+              <a:t>8/22/2026</a:t>
             </a:fld>
             <a:endParaRPr lang="en-US"/>
           </a:p>
@@ -2900,7 +4306,7 @@
           <a:p>
             <a:fld id="{D1F3894F-03A6-4760-8AFF-8C8908CB964C}" type="datetimeFigureOut">
               <a:rPr lang="en-US" smtClean="0"/>
-              <a:t>8/17/2026</a:t>
+              <a:t>8/22/2026</a:t>
             </a:fld>
             <a:endParaRPr lang="en-US"/>
           </a:p>
@@ -3305,7 +4711,7 @@
           <a:p>
             <a:fld id="{D1F3894F-03A6-4760-8AFF-8C8908CB964C}" type="datetimeFigureOut">
               <a:rPr lang="en-US" smtClean="0"/>
-              <a:t>8/17/2026</a:t>
+              <a:t>8/22/2026</a:t>
             </a:fld>
             <a:endParaRPr lang="en-US"/>
           </a:p>
@@ -3873,7 +5279,7 @@
           <a:p>
             <a:fld id="{D1F3894F-03A6-4760-8AFF-8C8908CB964C}" type="datetimeFigureOut">
               <a:rPr lang="en-US" smtClean="0"/>
-              <a:t>8/17/2026</a:t>
+              <a:t>8/22/2026</a:t>
             </a:fld>
             <a:endParaRPr lang="en-US"/>
           </a:p>
@@ -4554,7 +5960,7 @@
           <a:p>
             <a:fld id="{D1F3894F-03A6-4760-8AFF-8C8908CB964C}" type="datetimeFigureOut">
               <a:rPr lang="en-US" smtClean="0"/>
-              <a:t>8/17/2026</a:t>
+              <a:t>8/22/2026</a:t>
             </a:fld>
             <a:endParaRPr lang="en-US"/>
           </a:p>
@@ -5467,7 +6873,7 @@
           <a:p>
             <a:fld id="{D1F3894F-03A6-4760-8AFF-8C8908CB964C}" type="datetimeFigureOut">
               <a:rPr lang="en-US" smtClean="0"/>
-              <a:t>8/17/2026</a:t>
+              <a:t>8/22/2026</a:t>
             </a:fld>
             <a:endParaRPr lang="en-US"/>
           </a:p>
@@ -5780,7 +7186,7 @@
           <a:p>
             <a:fld id="{D1F3894F-03A6-4760-8AFF-8C8908CB964C}" type="datetimeFigureOut">
               <a:rPr lang="en-US" smtClean="0"/>
-              <a:t>8/17/2026</a:t>
+              <a:t>8/22/2026</a:t>
             </a:fld>
             <a:endParaRPr lang="en-US"/>
           </a:p>
@@ -6044,7 +7450,7 @@
           <a:p>
             <a:fld id="{D1F3894F-03A6-4760-8AFF-8C8908CB964C}" type="datetimeFigureOut">
               <a:rPr lang="en-US" smtClean="0"/>
-              <a:t>8/17/2026</a:t>
+              <a:t>8/22/2026</a:t>
             </a:fld>
             <a:endParaRPr lang="en-US"/>
           </a:p>
@@ -6238,7 +7644,7 @@
           <a:p>
             <a:fld id="{D1F3894F-03A6-4760-8AFF-8C8908CB964C}" type="datetimeFigureOut">
               <a:rPr lang="en-US" smtClean="0"/>
-              <a:t>8/17/2026</a:t>
+              <a:t>8/22/2026</a:t>
             </a:fld>
             <a:endParaRPr lang="en-US"/>
           </a:p>
@@ -6538,7 +7944,7 @@
           <a:p>
             <a:fld id="{D1F3894F-03A6-4760-8AFF-8C8908CB964C}" type="datetimeFigureOut">
               <a:rPr lang="en-US" smtClean="0"/>
-              <a:t>8/17/2026</a:t>
+              <a:t>8/22/2026</a:t>
             </a:fld>
             <a:endParaRPr lang="en-US"/>
           </a:p>
@@ -6927,7 +8333,7 @@
           <a:p>
             <a:fld id="{D1F3894F-03A6-4760-8AFF-8C8908CB964C}" type="datetimeFigureOut">
               <a:rPr lang="en-US" smtClean="0"/>
-              <a:t>8/17/2026</a:t>
+              <a:t>8/22/2026</a:t>
             </a:fld>
             <a:endParaRPr lang="en-US"/>
           </a:p>
@@ -7303,7 +8709,7 @@
           <a:p>
             <a:fld id="{D1F3894F-03A6-4760-8AFF-8C8908CB964C}" type="datetimeFigureOut">
               <a:rPr lang="en-US" smtClean="0"/>
-              <a:t>8/17/2026</a:t>
+              <a:t>8/22/2026</a:t>
             </a:fld>
             <a:endParaRPr lang="en-US"/>
           </a:p>
@@ -7897,7 +9303,7 @@
           <a:p>
             <a:fld id="{D1F3894F-03A6-4760-8AFF-8C8908CB964C}" type="datetimeFigureOut">
               <a:rPr lang="en-US" smtClean="0"/>
-              <a:t>8/17/2026</a:t>
+              <a:t>8/22/2026</a:t>
             </a:fld>
             <a:endParaRPr lang="en-US"/>
           </a:p>
@@ -8242,7 +9648,7 @@
           <a:p>
             <a:fld id="{D1F3894F-03A6-4760-8AFF-8C8908CB964C}" type="datetimeFigureOut">
               <a:rPr lang="en-US" smtClean="0"/>
-              <a:t>8/17/2026</a:t>
+              <a:t>8/22/2026</a:t>
             </a:fld>
             <a:endParaRPr lang="en-US"/>
           </a:p>
@@ -8493,7 +9899,7 @@
           <a:p>
             <a:fld id="{D1F3894F-03A6-4760-8AFF-8C8908CB964C}" type="datetimeFigureOut">
               <a:rPr lang="en-US" smtClean="0"/>
-              <a:t>8/17/2026</a:t>
+              <a:t>8/22/2026</a:t>
             </a:fld>
             <a:endParaRPr lang="en-US"/>
           </a:p>
@@ -8971,7 +10377,7 @@
           <a:p>
             <a:fld id="{D1F3894F-03A6-4760-8AFF-8C8908CB964C}" type="datetimeFigureOut">
               <a:rPr lang="en-US" smtClean="0"/>
-              <a:t>8/17/2026</a:t>
+              <a:t>8/22/2026</a:t>
             </a:fld>
             <a:endParaRPr lang="en-US"/>
           </a:p>
@@ -9380,7 +10786,7 @@
           <a:p>
             <a:fld id="{D1F3894F-03A6-4760-8AFF-8C8908CB964C}" type="datetimeFigureOut">
               <a:rPr lang="en-US" smtClean="0"/>
-              <a:t>8/17/2026</a:t>
+              <a:t>8/22/2026</a:t>
             </a:fld>
             <a:endParaRPr lang="en-US"/>
           </a:p>
@@ -9624,7 +11030,7 @@
           <a:p>
             <a:fld id="{D1F3894F-03A6-4760-8AFF-8C8908CB964C}" type="datetimeFigureOut">
               <a:rPr lang="en-US" smtClean="0"/>
-              <a:t>8/17/2026</a:t>
+              <a:t>8/22/2026</a:t>
             </a:fld>
             <a:endParaRPr lang="en-US"/>
           </a:p>
@@ -12248,7 +13654,7 @@
         <p:spPr>
           <a:xfrm>
             <a:off x="381600" y="632143"/>
-            <a:ext cx="6138219" cy="707886"/>
+            <a:ext cx="6288901" cy="707886"/>
           </a:xfrm>
           <a:prstGeom prst="rect">
             <a:avLst/>
@@ -12265,7 +13671,7 @@
               <a:rPr lang="fr-FR" sz="4000" dirty="0">
                 <a:latin typeface="Eras Demi ITC" panose="020B0805030504020804" pitchFamily="34" charset="0"/>
               </a:rPr>
-              <a:t>I</a:t>
+              <a:t>II</a:t>
             </a:r>
             <a:r>
               <a:rPr lang="fr-FR" sz="4000" noProof="0" dirty="0">
@@ -13258,43 +14664,6 @@
           </a:p>
         </p:txBody>
       </p:sp>
-      <p:pic>
-        <p:nvPicPr>
-          <p:cNvPr id="11" name="Image 10">
-            <a:extLst>
-              <a:ext uri="{FF2B5EF4-FFF2-40B4-BE49-F238E27FC236}">
-                <a16:creationId xmlns:a16="http://schemas.microsoft.com/office/drawing/2014/main" id="{1EE061D7-4D56-AED3-14EC-B6B045D49F74}"/>
-              </a:ext>
-            </a:extLst>
-          </p:cNvPr>
-          <p:cNvPicPr>
-            <a:picLocks noChangeAspect="1"/>
-          </p:cNvPicPr>
-          <p:nvPr/>
-        </p:nvPicPr>
-        <p:blipFill>
-          <a:blip r:embed="rId3">
-            <a:extLst>
-              <a:ext uri="{28A0092B-C50C-407E-A947-70E740481C1C}">
-                <a14:useLocalDpi xmlns:a14="http://schemas.microsoft.com/office/drawing/2010/main" val="0"/>
-              </a:ext>
-            </a:extLst>
-          </a:blip>
-          <a:srcRect l="30176" r="27750" b="68498"/>
-          <a:stretch>
-            <a:fillRect/>
-          </a:stretch>
-        </p:blipFill>
-        <p:spPr>
-          <a:xfrm>
-            <a:off x="5729527" y="1499753"/>
-            <a:ext cx="6210764" cy="5236327"/>
-          </a:xfrm>
-          <a:prstGeom prst="rect">
-            <a:avLst/>
-          </a:prstGeom>
-        </p:spPr>
-      </p:pic>
       <p:sp>
         <p:nvSpPr>
           <p:cNvPr id="13" name="ZoneTexte 12">

</xml_diff>